<commit_message>
refactor: redesign evaluation plan slide layout and visual components
</commit_message>
<xml_diff>
--- a/docs/presentation/files/CSE-810-PRESENTATION-INCEPTION.pptx
+++ b/docs/presentation/files/CSE-810-PRESENTATION-INCEPTION.pptx
@@ -23,30 +23,31 @@
     <p:sldId id="267" r:id="rId19"/>
     <p:sldId id="268" r:id="rId20"/>
     <p:sldId id="269" r:id="rId21"/>
+    <p:sldId id="270" r:id="rId22"/>
   </p:sldIdLst>
   <p:sldSz cy="5143500" cx="9144000"/>
   <p:notesSz cx="6858000" cy="9144000"/>
   <p:embeddedFontLst>
     <p:embeddedFont>
       <p:font typeface="Playfair Display"/>
-      <p:regular r:id="rId22"/>
-      <p:bold r:id="rId23"/>
-      <p:italic r:id="rId24"/>
-      <p:boldItalic r:id="rId25"/>
+      <p:regular r:id="rId23"/>
+      <p:bold r:id="rId24"/>
+      <p:italic r:id="rId25"/>
+      <p:boldItalic r:id="rId26"/>
     </p:embeddedFont>
     <p:embeddedFont>
       <p:font typeface="Source Sans 3"/>
-      <p:regular r:id="rId26"/>
-      <p:bold r:id="rId27"/>
-      <p:italic r:id="rId28"/>
-      <p:boldItalic r:id="rId29"/>
+      <p:regular r:id="rId27"/>
+      <p:bold r:id="rId28"/>
+      <p:italic r:id="rId29"/>
+      <p:boldItalic r:id="rId30"/>
     </p:embeddedFont>
     <p:embeddedFont>
       <p:font typeface="IBM Plex Mono"/>
-      <p:regular r:id="rId30"/>
-      <p:bold r:id="rId31"/>
-      <p:italic r:id="rId32"/>
-      <p:boldItalic r:id="rId33"/>
+      <p:regular r:id="rId31"/>
+      <p:bold r:id="rId32"/>
+      <p:italic r:id="rId33"/>
+      <p:boldItalic r:id="rId34"/>
     </p:embeddedFont>
   </p:embeddedFontLst>
   <p:defaultTextStyle>
@@ -1527,7 +1528,7 @@
       </p:grpSpPr>
       <p:sp>
         <p:nvSpPr>
-          <p:cNvPr id="544" name="Google Shape;544;g3f9fbdecd61_124_0:notes"/>
+          <p:cNvPr id="544" name="Google Shape;544;g3f9fbdecd61_135_0:notes"/>
           <p:cNvSpPr/>
           <p:nvPr>
             <p:ph idx="2" type="sldImg"/>
@@ -1572,7 +1573,7 @@
       </p:sp>
       <p:sp>
         <p:nvSpPr>
-          <p:cNvPr id="545" name="Google Shape;545;g3f9fbdecd61_124_0:notes"/>
+          <p:cNvPr id="545" name="Google Shape;545;g3f9fbdecd61_135_0:notes"/>
           <p:cNvSpPr txBox="1"/>
           <p:nvPr>
             <p:ph idx="1" type="body"/>
@@ -1615,7 +1616,164 @@
       </p:sp>
       <p:sp>
         <p:nvSpPr>
-          <p:cNvPr id="546" name="Google Shape;546;g3f9fbdecd61_124_0:notes"/>
+          <p:cNvPr id="546" name="Google Shape;546;g3f9fbdecd61_135_0:notes"/>
+          <p:cNvSpPr txBox="1"/>
+          <p:nvPr>
+            <p:ph idx="12" type="sldNum"/>
+          </p:nvPr>
+        </p:nvSpPr>
+        <p:spPr>
+          <a:xfrm>
+            <a:off x="3884613" y="6513910"/>
+            <a:ext cx="2971800" cy="344090"/>
+          </a:xfrm>
+          <a:prstGeom prst="rect">
+            <a:avLst/>
+          </a:prstGeom>
+          <a:noFill/>
+          <a:ln>
+            <a:noFill/>
+          </a:ln>
+        </p:spPr>
+        <p:txBody>
+          <a:bodyPr anchorCtr="0" anchor="b" bIns="45700" lIns="91425" spcFirstLastPara="1" rIns="91425" wrap="square" tIns="45700">
+            <a:noAutofit/>
+          </a:bodyPr>
+          <a:lstStyle/>
+          <a:p>
+            <a:pPr indent="0" lvl="0" marL="0" rtl="0" algn="r">
+              <a:spcBef>
+                <a:spcPts val="0"/>
+              </a:spcBef>
+              <a:spcAft>
+                <a:spcPts val="0"/>
+              </a:spcAft>
+              <a:buNone/>
+            </a:pPr>
+            <a:fld id="{00000000-1234-1234-1234-123412341234}" type="slidenum">
+              <a:rPr lang="en"/>
+              <a:t>‹#›</a:t>
+            </a:fld>
+            <a:endParaRPr/>
+          </a:p>
+        </p:txBody>
+      </p:sp>
+    </p:spTree>
+  </p:cSld>
+  <p:clrMapOvr>
+    <a:masterClrMapping/>
+  </p:clrMapOvr>
+</p:notes>
+</file>
+
+<file path=ppt/notesSlides/notesSlide15.xml><?xml version="1.0" encoding="utf-8"?>
+<p:notes xmlns:a="http://schemas.openxmlformats.org/drawingml/2006/main" xmlns:r="http://schemas.openxmlformats.org/officeDocument/2006/relationships" xmlns:mc="http://schemas.openxmlformats.org/markup-compatibility/2006" xmlns:mv="urn:schemas-microsoft-com:mac:vml" xmlns:p="http://schemas.openxmlformats.org/presentationml/2006/main" xmlns:c="http://schemas.openxmlformats.org/drawingml/2006/chart" xmlns:dgm="http://schemas.openxmlformats.org/drawingml/2006/diagram" xmlns:o="urn:schemas-microsoft-com:office:office" xmlns:v="urn:schemas-microsoft-com:vml" xmlns:pvml="urn:schemas-microsoft-com:office:powerpoint" xmlns:com="http://schemas.openxmlformats.org/drawingml/2006/compatibility" xmlns:p14="http://schemas.microsoft.com/office/powerpoint/2010/main" xmlns:p15="http://schemas.microsoft.com/office/powerpoint/2012/main" xmlns:ahyp="http://schemas.microsoft.com/office/drawing/2018/hyperlinkcolor" showMasterPhAnim="0" showMasterSp="0">
+  <p:cSld>
+    <p:spTree>
+      <p:nvGrpSpPr>
+        <p:cNvPr id="579" name="Shape 579"/>
+        <p:cNvGrpSpPr/>
+        <p:nvPr/>
+      </p:nvGrpSpPr>
+      <p:grpSpPr>
+        <a:xfrm>
+          <a:off x="0" y="0"/>
+          <a:ext cx="0" cy="0"/>
+          <a:chOff x="0" y="0"/>
+          <a:chExt cx="0" cy="0"/>
+        </a:xfrm>
+      </p:grpSpPr>
+      <p:sp>
+        <p:nvSpPr>
+          <p:cNvPr id="580" name="Google Shape;580;g3f9fbdecd61_141_0:notes"/>
+          <p:cNvSpPr/>
+          <p:nvPr>
+            <p:ph idx="2" type="sldImg"/>
+          </p:nvPr>
+        </p:nvSpPr>
+        <p:spPr>
+          <a:xfrm>
+            <a:off x="685800" y="857250"/>
+            <a:ext cx="5486400" cy="2314575"/>
+          </a:xfrm>
+          <a:custGeom>
+            <a:rect b="b" l="l" r="r" t="t"/>
+            <a:pathLst>
+              <a:path extrusionOk="0" h="120000" w="120000">
+                <a:moveTo>
+                  <a:pt x="0" y="0"/>
+                </a:moveTo>
+                <a:lnTo>
+                  <a:pt x="120000" y="0"/>
+                </a:lnTo>
+                <a:lnTo>
+                  <a:pt x="120000" y="120000"/>
+                </a:lnTo>
+                <a:lnTo>
+                  <a:pt x="0" y="120000"/>
+                </a:lnTo>
+                <a:close/>
+              </a:path>
+            </a:pathLst>
+          </a:custGeom>
+          <a:noFill/>
+          <a:ln cap="flat" cmpd="sng" w="12700">
+            <a:solidFill>
+              <a:srgbClr val="000000"/>
+            </a:solidFill>
+            <a:prstDash val="solid"/>
+            <a:round/>
+            <a:headEnd len="sm" w="sm" type="none"/>
+            <a:tailEnd len="sm" w="sm" type="none"/>
+          </a:ln>
+        </p:spPr>
+      </p:sp>
+      <p:sp>
+        <p:nvSpPr>
+          <p:cNvPr id="581" name="Google Shape;581;g3f9fbdecd61_141_0:notes"/>
+          <p:cNvSpPr txBox="1"/>
+          <p:nvPr>
+            <p:ph idx="1" type="body"/>
+          </p:nvPr>
+        </p:nvSpPr>
+        <p:spPr>
+          <a:xfrm>
+            <a:off x="685800" y="3300413"/>
+            <a:ext cx="5486400" cy="2700338"/>
+          </a:xfrm>
+          <a:prstGeom prst="rect">
+            <a:avLst/>
+          </a:prstGeom>
+          <a:noFill/>
+          <a:ln>
+            <a:noFill/>
+          </a:ln>
+        </p:spPr>
+        <p:txBody>
+          <a:bodyPr anchorCtr="0" anchor="t" bIns="45700" lIns="91425" spcFirstLastPara="1" rIns="91425" wrap="square" tIns="45700">
+            <a:noAutofit/>
+          </a:bodyPr>
+          <a:lstStyle/>
+          <a:p>
+            <a:pPr indent="0" lvl="0" marL="0" rtl="0" algn="l">
+              <a:spcBef>
+                <a:spcPts val="0"/>
+              </a:spcBef>
+              <a:spcAft>
+                <a:spcPts val="0"/>
+              </a:spcAft>
+              <a:buNone/>
+            </a:pPr>
+            <a:r>
+              <a:t/>
+            </a:r>
+            <a:endParaRPr/>
+          </a:p>
+        </p:txBody>
+      </p:sp>
+      <p:sp>
+        <p:nvSpPr>
+          <p:cNvPr id="582" name="Google Shape;582;g3f9fbdecd61_141_0:notes"/>
           <p:cNvSpPr txBox="1"/>
           <p:nvPr>
             <p:ph idx="12" type="sldNum"/>
@@ -8876,7 +9034,7 @@
             <a:tbl>
               <a:tblPr>
                 <a:noFill/>
-                <a:tableStyleId>{A18C39B4-9265-4439-AC4B-7F529FEAC824}</a:tableStyleId>
+                <a:tableStyleId>{25C997F3-B552-403A-BB00-0357DBA40DC2}</a:tableStyleId>
               </a:tblPr>
               <a:tblGrid>
                 <a:gridCol w="1571625"/>
@@ -18669,7 +18827,7 @@
             <a:r>
               <a:rPr b="0" i="0" lang="en" sz="700" u="none" cap="none" strike="noStrike">
                 <a:solidFill>
-                  <a:srgbClr val="9A9AAA"/>
+                  <a:schemeClr val="dk1"/>
                 </a:solidFill>
                 <a:latin typeface="IBM Plex Mono"/>
                 <a:ea typeface="IBM Plex Mono"/>
@@ -18976,7 +19134,7 @@
               </a:rPr>
               <a:t>Confirmed facts vs. attack hypotheses — kept strictly separate.</a:t>
             </a:r>
-            <a:endParaRPr b="0" i="0" sz="1200" u="none" cap="none" strike="noStrike">
+            <a:endParaRPr b="0" i="0" u="none" cap="none" strike="noStrike">
               <a:solidFill>
                 <a:schemeClr val="dk1"/>
               </a:solidFill>
@@ -18999,9 +19157,9 @@
             <a:off x="2314575" y="1271587"/>
             <a:ext cx="171450" cy="1600200"/>
           </a:xfrm>
-          <a:prstGeom prst="roundRect">
+          <a:prstGeom prst="rightBracket">
             <a:avLst>
-              <a:gd fmla="val 66667" name="adj"/>
+              <a:gd fmla="val 8333" name="adj"/>
             </a:avLst>
           </a:prstGeom>
           <a:noFill/>
@@ -19045,7 +19203,7 @@
         </p:nvSpPr>
         <p:spPr>
           <a:xfrm rot="5400000">
-            <a:off x="2507469" y="2000294"/>
+            <a:off x="2593231" y="1950356"/>
             <a:ext cx="99900" cy="142800"/>
           </a:xfrm>
           <a:prstGeom prst="triangle">
@@ -19091,7 +19249,7 @@
         <p:spPr>
           <a:xfrm>
             <a:off x="3114675" y="1143000"/>
-            <a:ext cx="14288" cy="464344"/>
+            <a:ext cx="14400" cy="464400"/>
           </a:xfrm>
           <a:prstGeom prst="rect">
             <a:avLst/>
@@ -19133,8 +19291,8 @@
         </p:nvSpPr>
         <p:spPr>
           <a:xfrm>
-            <a:off x="3114675" y="1607344"/>
-            <a:ext cx="14288" cy="464344"/>
+            <a:off x="3114666" y="1907375"/>
+            <a:ext cx="14400" cy="571500"/>
           </a:xfrm>
           <a:prstGeom prst="rect">
             <a:avLst/>
@@ -19176,8 +19334,8 @@
         </p:nvSpPr>
         <p:spPr>
           <a:xfrm>
-            <a:off x="3114675" y="2071688"/>
-            <a:ext cx="14288" cy="464344"/>
+            <a:off x="3114675" y="2478874"/>
+            <a:ext cx="14400" cy="521700"/>
           </a:xfrm>
           <a:prstGeom prst="rect">
             <a:avLst/>
@@ -19214,49 +19372,6 @@
       <p:sp>
         <p:nvSpPr>
           <p:cNvPr id="556" name="Google Shape;556;p28"/>
-          <p:cNvSpPr/>
-          <p:nvPr/>
-        </p:nvSpPr>
-        <p:spPr>
-          <a:xfrm>
-            <a:off x="3114675" y="2536031"/>
-            <a:ext cx="14288" cy="464344"/>
-          </a:xfrm>
-          <a:prstGeom prst="rect">
-            <a:avLst/>
-          </a:prstGeom>
-          <a:solidFill>
-            <a:srgbClr val="2A6B3C"/>
-          </a:solidFill>
-          <a:ln>
-            <a:noFill/>
-          </a:ln>
-        </p:spPr>
-        <p:txBody>
-          <a:bodyPr anchorCtr="0" anchor="ctr" bIns="68575" lIns="68575" spcFirstLastPara="1" rIns="68575" wrap="square" tIns="68575">
-            <a:noAutofit/>
-          </a:bodyPr>
-          <a:lstStyle/>
-          <a:p>
-            <a:pPr indent="0" lvl="0" marL="0" rtl="0" algn="l">
-              <a:spcBef>
-                <a:spcPts val="0"/>
-              </a:spcBef>
-              <a:spcAft>
-                <a:spcPts val="0"/>
-              </a:spcAft>
-              <a:buNone/>
-            </a:pPr>
-            <a:r>
-              <a:t/>
-            </a:r>
-            <a:endParaRPr/>
-          </a:p>
-        </p:txBody>
-      </p:sp>
-      <p:sp>
-        <p:nvSpPr>
-          <p:cNvPr id="557" name="Google Shape;557;p28"/>
           <p:cNvSpPr/>
           <p:nvPr/>
         </p:nvSpPr>
@@ -19305,7 +19420,7 @@
       </p:sp>
       <p:sp>
         <p:nvSpPr>
-          <p:cNvPr id="558" name="Google Shape;558;p28"/>
+          <p:cNvPr id="557" name="Google Shape;557;p28"/>
           <p:cNvSpPr txBox="1"/>
           <p:nvPr/>
         </p:nvSpPr>
@@ -19368,7 +19483,7 @@
       </p:sp>
       <p:sp>
         <p:nvSpPr>
-          <p:cNvPr id="559" name="Google Shape;559;p28"/>
+          <p:cNvPr id="558" name="Google Shape;558;p28"/>
           <p:cNvSpPr txBox="1"/>
           <p:nvPr/>
         </p:nvSpPr>
@@ -19431,7 +19546,7 @@
       </p:sp>
       <p:sp>
         <p:nvSpPr>
-          <p:cNvPr id="560" name="Google Shape;560;p28"/>
+          <p:cNvPr id="559" name="Google Shape;559;p28"/>
           <p:cNvSpPr txBox="1"/>
           <p:nvPr/>
         </p:nvSpPr>
@@ -19497,7 +19612,7 @@
       </p:sp>
       <p:sp>
         <p:nvSpPr>
-          <p:cNvPr id="561" name="Google Shape;561;p28"/>
+          <p:cNvPr id="560" name="Google Shape;560;p28"/>
           <p:cNvSpPr/>
           <p:nvPr/>
         </p:nvSpPr>
@@ -19546,7 +19661,7 @@
       </p:sp>
       <p:sp>
         <p:nvSpPr>
-          <p:cNvPr id="562" name="Google Shape;562;p28"/>
+          <p:cNvPr id="561" name="Google Shape;561;p28"/>
           <p:cNvSpPr txBox="1"/>
           <p:nvPr/>
         </p:nvSpPr>
@@ -19609,7 +19724,7 @@
       </p:sp>
       <p:sp>
         <p:nvSpPr>
-          <p:cNvPr id="563" name="Google Shape;563;p28"/>
+          <p:cNvPr id="562" name="Google Shape;562;p28"/>
           <p:cNvSpPr txBox="1"/>
           <p:nvPr/>
         </p:nvSpPr>
@@ -19672,7 +19787,7 @@
       </p:sp>
       <p:sp>
         <p:nvSpPr>
-          <p:cNvPr id="564" name="Google Shape;564;p28"/>
+          <p:cNvPr id="563" name="Google Shape;563;p28"/>
           <p:cNvSpPr txBox="1"/>
           <p:nvPr/>
         </p:nvSpPr>
@@ -19738,7 +19853,7 @@
       </p:sp>
       <p:sp>
         <p:nvSpPr>
-          <p:cNvPr id="565" name="Google Shape;565;p28"/>
+          <p:cNvPr id="564" name="Google Shape;564;p28"/>
           <p:cNvSpPr/>
           <p:nvPr/>
         </p:nvSpPr>
@@ -19787,7 +19902,7 @@
       </p:sp>
       <p:sp>
         <p:nvSpPr>
-          <p:cNvPr id="566" name="Google Shape;566;p28"/>
+          <p:cNvPr id="565" name="Google Shape;565;p28"/>
           <p:cNvSpPr txBox="1"/>
           <p:nvPr/>
         </p:nvSpPr>
@@ -19850,7 +19965,7 @@
       </p:sp>
       <p:sp>
         <p:nvSpPr>
-          <p:cNvPr id="567" name="Google Shape;567;p28"/>
+          <p:cNvPr id="566" name="Google Shape;566;p28"/>
           <p:cNvSpPr txBox="1"/>
           <p:nvPr/>
         </p:nvSpPr>
@@ -19913,7 +20028,7 @@
       </p:sp>
       <p:sp>
         <p:nvSpPr>
-          <p:cNvPr id="568" name="Google Shape;568;p28"/>
+          <p:cNvPr id="567" name="Google Shape;567;p28"/>
           <p:cNvSpPr txBox="1"/>
           <p:nvPr/>
         </p:nvSpPr>
@@ -19979,7 +20094,7 @@
       </p:sp>
       <p:sp>
         <p:nvSpPr>
-          <p:cNvPr id="569" name="Google Shape;569;p28"/>
+          <p:cNvPr id="568" name="Google Shape;568;p28"/>
           <p:cNvSpPr/>
           <p:nvPr/>
         </p:nvSpPr>
@@ -20028,7 +20143,7 @@
       </p:sp>
       <p:sp>
         <p:nvSpPr>
-          <p:cNvPr id="570" name="Google Shape;570;p28"/>
+          <p:cNvPr id="569" name="Google Shape;569;p28"/>
           <p:cNvSpPr txBox="1"/>
           <p:nvPr/>
         </p:nvSpPr>
@@ -20091,7 +20206,7 @@
       </p:sp>
       <p:sp>
         <p:nvSpPr>
-          <p:cNvPr id="571" name="Google Shape;571;p28"/>
+          <p:cNvPr id="570" name="Google Shape;570;p28"/>
           <p:cNvSpPr txBox="1"/>
           <p:nvPr/>
         </p:nvSpPr>
@@ -20154,7 +20269,7 @@
       </p:sp>
       <p:sp>
         <p:nvSpPr>
-          <p:cNvPr id="572" name="Google Shape;572;p28"/>
+          <p:cNvPr id="571" name="Google Shape;571;p28"/>
           <p:cNvSpPr txBox="1"/>
           <p:nvPr/>
         </p:nvSpPr>
@@ -20220,18 +20335,18 @@
       </p:sp>
       <p:sp>
         <p:nvSpPr>
-          <p:cNvPr id="573" name="Google Shape;573;p28"/>
+          <p:cNvPr id="572" name="Google Shape;572;p28"/>
           <p:cNvSpPr/>
           <p:nvPr/>
         </p:nvSpPr>
         <p:spPr>
-          <a:xfrm>
-            <a:off x="1771650" y="3414713"/>
-            <a:ext cx="5600700" cy="171450"/>
-          </a:xfrm>
-          <a:prstGeom prst="roundRect">
+          <a:xfrm rot="5400000">
+            <a:off x="4486275" y="700088"/>
+            <a:ext cx="171450" cy="5600700"/>
+          </a:xfrm>
+          <a:prstGeom prst="rightBracket">
             <a:avLst>
-              <a:gd fmla="val 50000" name="adj"/>
+              <a:gd fmla="val 8333" name="adj"/>
             </a:avLst>
           </a:prstGeom>
           <a:noFill/>
@@ -20269,14 +20384,14 @@
       </p:sp>
       <p:sp>
         <p:nvSpPr>
-          <p:cNvPr id="574" name="Google Shape;574;p28"/>
+          <p:cNvPr id="573" name="Google Shape;573;p28"/>
           <p:cNvSpPr/>
           <p:nvPr/>
         </p:nvSpPr>
         <p:spPr>
-          <a:xfrm>
-            <a:off x="4343400" y="3314700"/>
-            <a:ext cx="100013" cy="100013"/>
+          <a:xfrm rot="10800000">
+            <a:off x="4472088" y="3314825"/>
+            <a:ext cx="99900" cy="99900"/>
           </a:xfrm>
           <a:prstGeom prst="triangle">
             <a:avLst>
@@ -20314,7 +20429,7 @@
       </p:sp>
       <p:sp>
         <p:nvSpPr>
-          <p:cNvPr id="575" name="Google Shape;575;p28"/>
+          <p:cNvPr id="574" name="Google Shape;574;p28"/>
           <p:cNvSpPr txBox="1"/>
           <p:nvPr/>
         </p:nvSpPr>
@@ -20366,7 +20481,7 @@
               </a:rPr>
               <a:t>MEMORY</a:t>
             </a:r>
-            <a:endParaRPr b="0" i="0" sz="1100" u="none" cap="none" strike="noStrike">
+            <a:endParaRPr b="0" i="0" sz="800" u="none" cap="none" strike="noStrike">
               <a:solidFill>
                 <a:schemeClr val="dk1"/>
               </a:solidFill>
@@ -20406,7 +20521,7 @@
               </a:rPr>
               <a:t>Remembers strategies and failures. Reuses what worked.</a:t>
             </a:r>
-            <a:endParaRPr b="0" i="0" sz="1100" u="none" cap="none" strike="noStrike">
+            <a:endParaRPr b="0" i="0" u="none" cap="none" strike="noStrike">
               <a:solidFill>
                 <a:schemeClr val="dk1"/>
               </a:solidFill>
@@ -20420,7 +20535,7 @@
       </p:sp>
       <p:sp>
         <p:nvSpPr>
-          <p:cNvPr id="576" name="Google Shape;576;p28"/>
+          <p:cNvPr id="575" name="Google Shape;575;p28"/>
           <p:cNvSpPr/>
           <p:nvPr/>
         </p:nvSpPr>
@@ -20463,7 +20578,7 @@
       </p:sp>
       <p:sp>
         <p:nvSpPr>
-          <p:cNvPr id="577" name="Google Shape;577;p28"/>
+          <p:cNvPr id="576" name="Google Shape;576;p28"/>
           <p:cNvSpPr txBox="1"/>
           <p:nvPr/>
         </p:nvSpPr>
@@ -20526,7 +20641,7 @@
       </p:sp>
       <p:sp>
         <p:nvSpPr>
-          <p:cNvPr id="578" name="Google Shape;578;p28"/>
+          <p:cNvPr id="577" name="Google Shape;577;p28"/>
           <p:cNvSpPr txBox="1"/>
           <p:nvPr/>
         </p:nvSpPr>
@@ -20589,7 +20704,7 @@
       </p:sp>
       <p:sp>
         <p:nvSpPr>
-          <p:cNvPr id="579" name="Google Shape;579;p28"/>
+          <p:cNvPr id="578" name="Google Shape;578;p28"/>
           <p:cNvSpPr/>
           <p:nvPr/>
         </p:nvSpPr>
@@ -20597,6 +20712,2158 @@
           <a:xfrm>
             <a:off x="0" y="5122069"/>
             <a:ext cx="5943600" cy="21431"/>
+          </a:xfrm>
+          <a:prstGeom prst="rect">
+            <a:avLst/>
+          </a:prstGeom>
+          <a:solidFill>
+            <a:srgbClr val="8B1A1A"/>
+          </a:solidFill>
+          <a:ln>
+            <a:noFill/>
+          </a:ln>
+        </p:spPr>
+        <p:txBody>
+          <a:bodyPr anchorCtr="0" anchor="ctr" bIns="68575" lIns="68575" spcFirstLastPara="1" rIns="68575" wrap="square" tIns="68575">
+            <a:noAutofit/>
+          </a:bodyPr>
+          <a:lstStyle/>
+          <a:p>
+            <a:pPr indent="0" lvl="0" marL="0" rtl="0" algn="l">
+              <a:spcBef>
+                <a:spcPts val="0"/>
+              </a:spcBef>
+              <a:spcAft>
+                <a:spcPts val="0"/>
+              </a:spcAft>
+              <a:buNone/>
+            </a:pPr>
+            <a:r>
+              <a:t/>
+            </a:r>
+            <a:endParaRPr/>
+          </a:p>
+        </p:txBody>
+      </p:sp>
+    </p:spTree>
+  </p:cSld>
+  <p:clrMapOvr>
+    <a:masterClrMapping/>
+  </p:clrMapOvr>
+</p:sld>
+</file>
+
+<file path=ppt/slides/slide15.xml><?xml version="1.0" encoding="utf-8"?>
+<p:sld xmlns:a="http://schemas.openxmlformats.org/drawingml/2006/main" xmlns:r="http://schemas.openxmlformats.org/officeDocument/2006/relationships" xmlns:mc="http://schemas.openxmlformats.org/markup-compatibility/2006" xmlns:mv="urn:schemas-microsoft-com:mac:vml" xmlns:p="http://schemas.openxmlformats.org/presentationml/2006/main" xmlns:c="http://schemas.openxmlformats.org/drawingml/2006/chart" xmlns:dgm="http://schemas.openxmlformats.org/drawingml/2006/diagram" xmlns:o="urn:schemas-microsoft-com:office:office" xmlns:v="urn:schemas-microsoft-com:vml" xmlns:pvml="urn:schemas-microsoft-com:office:powerpoint" xmlns:com="http://schemas.openxmlformats.org/drawingml/2006/compatibility" xmlns:p14="http://schemas.microsoft.com/office/powerpoint/2010/main" xmlns:p15="http://schemas.microsoft.com/office/powerpoint/2012/main" xmlns:ahyp="http://schemas.microsoft.com/office/drawing/2018/hyperlinkcolor">
+  <p:cSld>
+    <p:bg>
+      <p:bgPr>
+        <a:solidFill>
+          <a:srgbClr val="F7F4EF"/>
+        </a:solidFill>
+      </p:bgPr>
+    </p:bg>
+    <p:spTree>
+      <p:nvGrpSpPr>
+        <p:cNvPr id="583" name="Shape 583"/>
+        <p:cNvGrpSpPr/>
+        <p:nvPr/>
+      </p:nvGrpSpPr>
+      <p:grpSpPr>
+        <a:xfrm>
+          <a:off x="0" y="0"/>
+          <a:ext cx="0" cy="0"/>
+          <a:chOff x="0" y="0"/>
+          <a:chExt cx="0" cy="0"/>
+        </a:xfrm>
+      </p:grpSpPr>
+      <p:sp>
+        <p:nvSpPr>
+          <p:cNvPr id="584" name="Google Shape;584;p29"/>
+          <p:cNvSpPr txBox="1"/>
+          <p:nvPr/>
+        </p:nvSpPr>
+        <p:spPr>
+          <a:xfrm>
+            <a:off x="571501" y="271463"/>
+            <a:ext cx="7429524" cy="414339"/>
+          </a:xfrm>
+          <a:prstGeom prst="rect">
+            <a:avLst/>
+          </a:prstGeom>
+          <a:noFill/>
+          <a:ln>
+            <a:noFill/>
+          </a:ln>
+        </p:spPr>
+        <p:txBody>
+          <a:bodyPr anchorCtr="0" anchor="t" bIns="0" lIns="0" spcFirstLastPara="1" rIns="0" wrap="square" tIns="0">
+            <a:noAutofit/>
+          </a:bodyPr>
+          <a:lstStyle/>
+          <a:p>
+            <a:pPr indent="0" lvl="0" marL="0" marR="0" rtl="0" algn="l">
+              <a:spcBef>
+                <a:spcPts val="0"/>
+              </a:spcBef>
+              <a:spcAft>
+                <a:spcPts val="0"/>
+              </a:spcAft>
+              <a:buClr>
+                <a:srgbClr val="1A1A2E"/>
+              </a:buClr>
+              <a:buSzPts val="2400"/>
+              <a:buFont typeface="Playfair Display"/>
+              <a:buNone/>
+            </a:pPr>
+            <a:r>
+              <a:rPr b="1" i="0" lang="en" sz="2400" u="none" cap="none" strike="noStrike">
+                <a:solidFill>
+                  <a:srgbClr val="1A1A2E"/>
+                </a:solidFill>
+                <a:latin typeface="Playfair Display"/>
+                <a:ea typeface="Playfair Display"/>
+                <a:cs typeface="Playfair Display"/>
+                <a:sym typeface="Playfair Display"/>
+              </a:rPr>
+              <a:t>How RedGrid Will Work</a:t>
+            </a:r>
+            <a:endParaRPr b="0" i="0" sz="2400" u="none" cap="none" strike="noStrike">
+              <a:solidFill>
+                <a:schemeClr val="dk1"/>
+              </a:solidFill>
+              <a:latin typeface="Calibri"/>
+              <a:ea typeface="Calibri"/>
+              <a:cs typeface="Calibri"/>
+              <a:sym typeface="Calibri"/>
+            </a:endParaRPr>
+          </a:p>
+        </p:txBody>
+      </p:sp>
+      <p:sp>
+        <p:nvSpPr>
+          <p:cNvPr id="585" name="Google Shape;585;p29"/>
+          <p:cNvSpPr/>
+          <p:nvPr/>
+        </p:nvSpPr>
+        <p:spPr>
+          <a:xfrm>
+            <a:off x="571501" y="735809"/>
+            <a:ext cx="4086238" cy="21431"/>
+          </a:xfrm>
+          <a:prstGeom prst="rect">
+            <a:avLst/>
+          </a:prstGeom>
+          <a:solidFill>
+            <a:srgbClr val="8B1A1A"/>
+          </a:solidFill>
+          <a:ln>
+            <a:noFill/>
+          </a:ln>
+        </p:spPr>
+        <p:txBody>
+          <a:bodyPr anchorCtr="0" anchor="ctr" bIns="68575" lIns="68575" spcFirstLastPara="1" rIns="68575" wrap="square" tIns="68575">
+            <a:noAutofit/>
+          </a:bodyPr>
+          <a:lstStyle/>
+          <a:p>
+            <a:pPr indent="0" lvl="0" marL="0" rtl="0" algn="l">
+              <a:spcBef>
+                <a:spcPts val="0"/>
+              </a:spcBef>
+              <a:spcAft>
+                <a:spcPts val="0"/>
+              </a:spcAft>
+              <a:buNone/>
+            </a:pPr>
+            <a:r>
+              <a:t/>
+            </a:r>
+            <a:endParaRPr/>
+          </a:p>
+        </p:txBody>
+      </p:sp>
+      <p:sp>
+        <p:nvSpPr>
+          <p:cNvPr id="586" name="Google Shape;586;p29"/>
+          <p:cNvSpPr/>
+          <p:nvPr/>
+        </p:nvSpPr>
+        <p:spPr>
+          <a:xfrm>
+            <a:off x="3429011" y="1428755"/>
+            <a:ext cx="2286007" cy="1714505"/>
+          </a:xfrm>
+          <a:prstGeom prst="ellipse">
+            <a:avLst/>
+          </a:prstGeom>
+          <a:noFill/>
+          <a:ln cap="flat" cmpd="sng" w="15225">
+            <a:solidFill>
+              <a:srgbClr val="1A1A2E"/>
+            </a:solidFill>
+            <a:prstDash val="dash"/>
+            <a:round/>
+            <a:headEnd len="sm" w="sm" type="none"/>
+            <a:tailEnd len="sm" w="sm" type="none"/>
+          </a:ln>
+        </p:spPr>
+        <p:txBody>
+          <a:bodyPr anchorCtr="0" anchor="ctr" bIns="68575" lIns="68575" spcFirstLastPara="1" rIns="68575" wrap="square" tIns="68575">
+            <a:noAutofit/>
+          </a:bodyPr>
+          <a:lstStyle/>
+          <a:p>
+            <a:pPr indent="0" lvl="0" marL="0" rtl="0" algn="l">
+              <a:spcBef>
+                <a:spcPts val="0"/>
+              </a:spcBef>
+              <a:spcAft>
+                <a:spcPts val="0"/>
+              </a:spcAft>
+              <a:buNone/>
+            </a:pPr>
+            <a:r>
+              <a:t/>
+            </a:r>
+            <a:endParaRPr/>
+          </a:p>
+        </p:txBody>
+      </p:sp>
+      <p:sp>
+        <p:nvSpPr>
+          <p:cNvPr id="587" name="Google Shape;587;p29"/>
+          <p:cNvSpPr/>
+          <p:nvPr/>
+        </p:nvSpPr>
+        <p:spPr>
+          <a:xfrm>
+            <a:off x="2428882" y="928691"/>
+            <a:ext cx="2000257" cy="1000128"/>
+          </a:xfrm>
+          <a:prstGeom prst="roundRect">
+            <a:avLst>
+              <a:gd fmla="val 5486" name="adj"/>
+            </a:avLst>
+          </a:prstGeom>
+          <a:solidFill>
+            <a:srgbClr val="EADAD5"/>
+          </a:solidFill>
+          <a:ln cap="flat" cmpd="sng" w="19050">
+            <a:solidFill>
+              <a:srgbClr val="8B1A1A"/>
+            </a:solidFill>
+            <a:prstDash val="solid"/>
+            <a:round/>
+            <a:headEnd len="sm" w="sm" type="none"/>
+            <a:tailEnd len="sm" w="sm" type="none"/>
+          </a:ln>
+          <a:effectLst>
+            <a:outerShdw blurRad="152400" rotWithShape="0" algn="bl" dir="5400000" dist="50800">
+              <a:srgbClr val="000000">
+                <a:alpha val="5098"/>
+              </a:srgbClr>
+            </a:outerShdw>
+          </a:effectLst>
+        </p:spPr>
+        <p:txBody>
+          <a:bodyPr anchorCtr="0" anchor="ctr" bIns="68575" lIns="68575" spcFirstLastPara="1" rIns="68575" wrap="square" tIns="68575">
+            <a:noAutofit/>
+          </a:bodyPr>
+          <a:lstStyle/>
+          <a:p>
+            <a:pPr indent="0" lvl="0" marL="0" rtl="0" algn="l">
+              <a:spcBef>
+                <a:spcPts val="0"/>
+              </a:spcBef>
+              <a:spcAft>
+                <a:spcPts val="0"/>
+              </a:spcAft>
+              <a:buNone/>
+            </a:pPr>
+            <a:r>
+              <a:t/>
+            </a:r>
+            <a:endParaRPr/>
+          </a:p>
+        </p:txBody>
+      </p:sp>
+      <p:sp>
+        <p:nvSpPr>
+          <p:cNvPr id="588" name="Google Shape;588;p29"/>
+          <p:cNvSpPr/>
+          <p:nvPr/>
+        </p:nvSpPr>
+        <p:spPr>
+          <a:xfrm>
+            <a:off x="2543183" y="1042991"/>
+            <a:ext cx="200026" cy="200026"/>
+          </a:xfrm>
+          <a:prstGeom prst="ellipse">
+            <a:avLst/>
+          </a:prstGeom>
+          <a:solidFill>
+            <a:srgbClr val="FFFFFF"/>
+          </a:solidFill>
+          <a:ln cap="flat" cmpd="sng" w="15225">
+            <a:solidFill>
+              <a:srgbClr val="8B1A1A"/>
+            </a:solidFill>
+            <a:prstDash val="solid"/>
+            <a:round/>
+            <a:headEnd len="sm" w="sm" type="none"/>
+            <a:tailEnd len="sm" w="sm" type="none"/>
+          </a:ln>
+        </p:spPr>
+        <p:txBody>
+          <a:bodyPr anchorCtr="0" anchor="ctr" bIns="68575" lIns="68575" spcFirstLastPara="1" rIns="68575" wrap="square" tIns="68575">
+            <a:noAutofit/>
+          </a:bodyPr>
+          <a:lstStyle/>
+          <a:p>
+            <a:pPr indent="0" lvl="0" marL="0" rtl="0" algn="l">
+              <a:spcBef>
+                <a:spcPts val="0"/>
+              </a:spcBef>
+              <a:spcAft>
+                <a:spcPts val="0"/>
+              </a:spcAft>
+              <a:buNone/>
+            </a:pPr>
+            <a:r>
+              <a:t/>
+            </a:r>
+            <a:endParaRPr/>
+          </a:p>
+        </p:txBody>
+      </p:sp>
+      <p:sp>
+        <p:nvSpPr>
+          <p:cNvPr id="589" name="Google Shape;589;p29"/>
+          <p:cNvSpPr txBox="1"/>
+          <p:nvPr/>
+        </p:nvSpPr>
+        <p:spPr>
+          <a:xfrm>
+            <a:off x="2543183" y="1042991"/>
+            <a:ext cx="200026" cy="200026"/>
+          </a:xfrm>
+          <a:prstGeom prst="rect">
+            <a:avLst/>
+          </a:prstGeom>
+          <a:noFill/>
+          <a:ln>
+            <a:noFill/>
+          </a:ln>
+        </p:spPr>
+        <p:txBody>
+          <a:bodyPr anchorCtr="0" anchor="ctr" bIns="0" lIns="0" spcFirstLastPara="1" rIns="0" wrap="square" tIns="0">
+            <a:noAutofit/>
+          </a:bodyPr>
+          <a:lstStyle/>
+          <a:p>
+            <a:pPr indent="0" lvl="0" marL="0" marR="0" rtl="0" algn="ctr">
+              <a:spcBef>
+                <a:spcPts val="0"/>
+              </a:spcBef>
+              <a:spcAft>
+                <a:spcPts val="0"/>
+              </a:spcAft>
+              <a:buClr>
+                <a:srgbClr val="8B1A1A"/>
+              </a:buClr>
+              <a:buSzPts val="900"/>
+              <a:buFont typeface="IBM Plex Mono"/>
+              <a:buNone/>
+            </a:pPr>
+            <a:r>
+              <a:rPr b="1" i="0" lang="en" sz="900" u="none" cap="none" strike="noStrike">
+                <a:solidFill>
+                  <a:srgbClr val="8B1A1A"/>
+                </a:solidFill>
+                <a:latin typeface="IBM Plex Mono"/>
+                <a:ea typeface="IBM Plex Mono"/>
+                <a:cs typeface="IBM Plex Mono"/>
+                <a:sym typeface="IBM Plex Mono"/>
+              </a:rPr>
+              <a:t>1</a:t>
+            </a:r>
+            <a:endParaRPr b="0" i="0" sz="900" u="none" cap="none" strike="noStrike">
+              <a:solidFill>
+                <a:schemeClr val="dk1"/>
+              </a:solidFill>
+              <a:latin typeface="Calibri"/>
+              <a:ea typeface="Calibri"/>
+              <a:cs typeface="Calibri"/>
+              <a:sym typeface="Calibri"/>
+            </a:endParaRPr>
+          </a:p>
+        </p:txBody>
+      </p:sp>
+      <p:sp>
+        <p:nvSpPr>
+          <p:cNvPr id="590" name="Google Shape;590;p29"/>
+          <p:cNvSpPr txBox="1"/>
+          <p:nvPr/>
+        </p:nvSpPr>
+        <p:spPr>
+          <a:xfrm>
+            <a:off x="2814647" y="1042991"/>
+            <a:ext cx="1428755" cy="200026"/>
+          </a:xfrm>
+          <a:prstGeom prst="rect">
+            <a:avLst/>
+          </a:prstGeom>
+          <a:noFill/>
+          <a:ln>
+            <a:noFill/>
+          </a:ln>
+        </p:spPr>
+        <p:txBody>
+          <a:bodyPr anchorCtr="0" anchor="ctr" bIns="0" lIns="0" spcFirstLastPara="1" rIns="0" wrap="square" tIns="0">
+            <a:noAutofit/>
+          </a:bodyPr>
+          <a:lstStyle/>
+          <a:p>
+            <a:pPr indent="0" lvl="0" marL="0" marR="0" rtl="0" algn="l">
+              <a:spcBef>
+                <a:spcPts val="0"/>
+              </a:spcBef>
+              <a:spcAft>
+                <a:spcPts val="0"/>
+              </a:spcAft>
+              <a:buClr>
+                <a:srgbClr val="1A1A2E"/>
+              </a:buClr>
+              <a:buSzPts val="1400"/>
+              <a:buFont typeface="Source Sans 3"/>
+              <a:buNone/>
+            </a:pPr>
+            <a:r>
+              <a:rPr b="1" i="0" lang="en" sz="1400" u="none" cap="none" strike="noStrike">
+                <a:solidFill>
+                  <a:srgbClr val="1A1A2E"/>
+                </a:solidFill>
+                <a:latin typeface="Source Sans 3"/>
+                <a:ea typeface="Source Sans 3"/>
+                <a:cs typeface="Source Sans 3"/>
+                <a:sym typeface="Source Sans 3"/>
+              </a:rPr>
+              <a:t>Recon</a:t>
+            </a:r>
+            <a:endParaRPr b="0" i="0" sz="1400" u="none" cap="none" strike="noStrike">
+              <a:solidFill>
+                <a:schemeClr val="dk1"/>
+              </a:solidFill>
+              <a:latin typeface="Calibri"/>
+              <a:ea typeface="Calibri"/>
+              <a:cs typeface="Calibri"/>
+              <a:sym typeface="Calibri"/>
+            </a:endParaRPr>
+          </a:p>
+        </p:txBody>
+      </p:sp>
+      <p:sp>
+        <p:nvSpPr>
+          <p:cNvPr id="591" name="Google Shape;591;p29"/>
+          <p:cNvSpPr txBox="1"/>
+          <p:nvPr/>
+        </p:nvSpPr>
+        <p:spPr>
+          <a:xfrm>
+            <a:off x="2571758" y="1328742"/>
+            <a:ext cx="1714505" cy="500064"/>
+          </a:xfrm>
+          <a:prstGeom prst="rect">
+            <a:avLst/>
+          </a:prstGeom>
+          <a:noFill/>
+          <a:ln>
+            <a:noFill/>
+          </a:ln>
+        </p:spPr>
+        <p:txBody>
+          <a:bodyPr anchorCtr="0" anchor="t" bIns="0" lIns="0" spcFirstLastPara="1" rIns="0" wrap="square" tIns="0">
+            <a:noAutofit/>
+          </a:bodyPr>
+          <a:lstStyle/>
+          <a:p>
+            <a:pPr indent="0" lvl="0" marL="0" marR="0" rtl="0" algn="l">
+              <a:lnSpc>
+                <a:spcPct val="130000"/>
+              </a:lnSpc>
+              <a:spcBef>
+                <a:spcPts val="0"/>
+              </a:spcBef>
+              <a:spcAft>
+                <a:spcPts val="0"/>
+              </a:spcAft>
+              <a:buClr>
+                <a:srgbClr val="4A4A5E"/>
+              </a:buClr>
+              <a:buSzPts val="900"/>
+              <a:buFont typeface="Source Sans 3"/>
+              <a:buNone/>
+            </a:pPr>
+            <a:r>
+              <a:rPr b="1" i="0" lang="en" sz="900" u="none" cap="none" strike="noStrike">
+                <a:solidFill>
+                  <a:srgbClr val="4A4A5E"/>
+                </a:solidFill>
+                <a:latin typeface="Source Sans 3"/>
+                <a:ea typeface="Source Sans 3"/>
+                <a:cs typeface="Source Sans 3"/>
+                <a:sym typeface="Source Sans 3"/>
+              </a:rPr>
+              <a:t>Scan the target. Build a picture of what’s there.</a:t>
+            </a:r>
+            <a:endParaRPr b="0" i="0" sz="900" u="none" cap="none" strike="noStrike">
+              <a:solidFill>
+                <a:schemeClr val="dk1"/>
+              </a:solidFill>
+              <a:latin typeface="Calibri"/>
+              <a:ea typeface="Calibri"/>
+              <a:cs typeface="Calibri"/>
+              <a:sym typeface="Calibri"/>
+            </a:endParaRPr>
+          </a:p>
+        </p:txBody>
+      </p:sp>
+      <p:sp>
+        <p:nvSpPr>
+          <p:cNvPr id="592" name="Google Shape;592;p29"/>
+          <p:cNvSpPr/>
+          <p:nvPr/>
+        </p:nvSpPr>
+        <p:spPr>
+          <a:xfrm>
+            <a:off x="4714890" y="928691"/>
+            <a:ext cx="2000257" cy="1000128"/>
+          </a:xfrm>
+          <a:prstGeom prst="roundRect">
+            <a:avLst>
+              <a:gd fmla="val 5486" name="adj"/>
+            </a:avLst>
+          </a:prstGeom>
+          <a:solidFill>
+            <a:srgbClr val="DFE0E1"/>
+          </a:solidFill>
+          <a:ln cap="flat" cmpd="sng" w="19050">
+            <a:solidFill>
+              <a:srgbClr val="2E4A7A"/>
+            </a:solidFill>
+            <a:prstDash val="solid"/>
+            <a:round/>
+            <a:headEnd len="sm" w="sm" type="none"/>
+            <a:tailEnd len="sm" w="sm" type="none"/>
+          </a:ln>
+          <a:effectLst>
+            <a:outerShdw blurRad="152400" rotWithShape="0" algn="bl" dir="5400000" dist="50800">
+              <a:srgbClr val="000000">
+                <a:alpha val="5098"/>
+              </a:srgbClr>
+            </a:outerShdw>
+          </a:effectLst>
+        </p:spPr>
+        <p:txBody>
+          <a:bodyPr anchorCtr="0" anchor="ctr" bIns="68575" lIns="68575" spcFirstLastPara="1" rIns="68575" wrap="square" tIns="68575">
+            <a:noAutofit/>
+          </a:bodyPr>
+          <a:lstStyle/>
+          <a:p>
+            <a:pPr indent="0" lvl="0" marL="0" rtl="0" algn="l">
+              <a:spcBef>
+                <a:spcPts val="0"/>
+              </a:spcBef>
+              <a:spcAft>
+                <a:spcPts val="0"/>
+              </a:spcAft>
+              <a:buNone/>
+            </a:pPr>
+            <a:r>
+              <a:t/>
+            </a:r>
+            <a:endParaRPr/>
+          </a:p>
+        </p:txBody>
+      </p:sp>
+      <p:sp>
+        <p:nvSpPr>
+          <p:cNvPr id="593" name="Google Shape;593;p29"/>
+          <p:cNvSpPr/>
+          <p:nvPr/>
+        </p:nvSpPr>
+        <p:spPr>
+          <a:xfrm>
+            <a:off x="4829191" y="1042991"/>
+            <a:ext cx="200026" cy="200026"/>
+          </a:xfrm>
+          <a:prstGeom prst="ellipse">
+            <a:avLst/>
+          </a:prstGeom>
+          <a:solidFill>
+            <a:srgbClr val="FFFFFF"/>
+          </a:solidFill>
+          <a:ln cap="flat" cmpd="sng" w="15225">
+            <a:solidFill>
+              <a:srgbClr val="2E4A7A"/>
+            </a:solidFill>
+            <a:prstDash val="solid"/>
+            <a:round/>
+            <a:headEnd len="sm" w="sm" type="none"/>
+            <a:tailEnd len="sm" w="sm" type="none"/>
+          </a:ln>
+        </p:spPr>
+        <p:txBody>
+          <a:bodyPr anchorCtr="0" anchor="ctr" bIns="68575" lIns="68575" spcFirstLastPara="1" rIns="68575" wrap="square" tIns="68575">
+            <a:noAutofit/>
+          </a:bodyPr>
+          <a:lstStyle/>
+          <a:p>
+            <a:pPr indent="0" lvl="0" marL="0" rtl="0" algn="l">
+              <a:spcBef>
+                <a:spcPts val="0"/>
+              </a:spcBef>
+              <a:spcAft>
+                <a:spcPts val="0"/>
+              </a:spcAft>
+              <a:buNone/>
+            </a:pPr>
+            <a:r>
+              <a:t/>
+            </a:r>
+            <a:endParaRPr/>
+          </a:p>
+        </p:txBody>
+      </p:sp>
+      <p:sp>
+        <p:nvSpPr>
+          <p:cNvPr id="594" name="Google Shape;594;p29"/>
+          <p:cNvSpPr txBox="1"/>
+          <p:nvPr/>
+        </p:nvSpPr>
+        <p:spPr>
+          <a:xfrm>
+            <a:off x="4829191" y="1042991"/>
+            <a:ext cx="200026" cy="200026"/>
+          </a:xfrm>
+          <a:prstGeom prst="rect">
+            <a:avLst/>
+          </a:prstGeom>
+          <a:noFill/>
+          <a:ln>
+            <a:noFill/>
+          </a:ln>
+        </p:spPr>
+        <p:txBody>
+          <a:bodyPr anchorCtr="0" anchor="ctr" bIns="0" lIns="0" spcFirstLastPara="1" rIns="0" wrap="square" tIns="0">
+            <a:noAutofit/>
+          </a:bodyPr>
+          <a:lstStyle/>
+          <a:p>
+            <a:pPr indent="0" lvl="0" marL="0" marR="0" rtl="0" algn="ctr">
+              <a:spcBef>
+                <a:spcPts val="0"/>
+              </a:spcBef>
+              <a:spcAft>
+                <a:spcPts val="0"/>
+              </a:spcAft>
+              <a:buClr>
+                <a:srgbClr val="2E4A7A"/>
+              </a:buClr>
+              <a:buSzPts val="900"/>
+              <a:buFont typeface="IBM Plex Mono"/>
+              <a:buNone/>
+            </a:pPr>
+            <a:r>
+              <a:rPr b="1" i="0" lang="en" sz="900" u="none" cap="none" strike="noStrike">
+                <a:solidFill>
+                  <a:srgbClr val="2E4A7A"/>
+                </a:solidFill>
+                <a:latin typeface="IBM Plex Mono"/>
+                <a:ea typeface="IBM Plex Mono"/>
+                <a:cs typeface="IBM Plex Mono"/>
+                <a:sym typeface="IBM Plex Mono"/>
+              </a:rPr>
+              <a:t>2</a:t>
+            </a:r>
+            <a:endParaRPr b="0" i="0" sz="900" u="none" cap="none" strike="noStrike">
+              <a:solidFill>
+                <a:schemeClr val="dk1"/>
+              </a:solidFill>
+              <a:latin typeface="Calibri"/>
+              <a:ea typeface="Calibri"/>
+              <a:cs typeface="Calibri"/>
+              <a:sym typeface="Calibri"/>
+            </a:endParaRPr>
+          </a:p>
+        </p:txBody>
+      </p:sp>
+      <p:sp>
+        <p:nvSpPr>
+          <p:cNvPr id="595" name="Google Shape;595;p29"/>
+          <p:cNvSpPr txBox="1"/>
+          <p:nvPr/>
+        </p:nvSpPr>
+        <p:spPr>
+          <a:xfrm>
+            <a:off x="5100654" y="1042991"/>
+            <a:ext cx="1428755" cy="200026"/>
+          </a:xfrm>
+          <a:prstGeom prst="rect">
+            <a:avLst/>
+          </a:prstGeom>
+          <a:noFill/>
+          <a:ln>
+            <a:noFill/>
+          </a:ln>
+        </p:spPr>
+        <p:txBody>
+          <a:bodyPr anchorCtr="0" anchor="ctr" bIns="0" lIns="0" spcFirstLastPara="1" rIns="0" wrap="square" tIns="0">
+            <a:noAutofit/>
+          </a:bodyPr>
+          <a:lstStyle/>
+          <a:p>
+            <a:pPr indent="0" lvl="0" marL="0" marR="0" rtl="0" algn="l">
+              <a:spcBef>
+                <a:spcPts val="0"/>
+              </a:spcBef>
+              <a:spcAft>
+                <a:spcPts val="0"/>
+              </a:spcAft>
+              <a:buClr>
+                <a:srgbClr val="1A1A2E"/>
+              </a:buClr>
+              <a:buSzPts val="1400"/>
+              <a:buFont typeface="Source Sans 3"/>
+              <a:buNone/>
+            </a:pPr>
+            <a:r>
+              <a:rPr b="1" i="0" lang="en" sz="1400" u="none" cap="none" strike="noStrike">
+                <a:solidFill>
+                  <a:srgbClr val="1A1A2E"/>
+                </a:solidFill>
+                <a:latin typeface="Source Sans 3"/>
+                <a:ea typeface="Source Sans 3"/>
+                <a:cs typeface="Source Sans 3"/>
+                <a:sym typeface="Source Sans 3"/>
+              </a:rPr>
+              <a:t>Plan</a:t>
+            </a:r>
+            <a:endParaRPr b="0" i="0" sz="1400" u="none" cap="none" strike="noStrike">
+              <a:solidFill>
+                <a:schemeClr val="dk1"/>
+              </a:solidFill>
+              <a:latin typeface="Calibri"/>
+              <a:ea typeface="Calibri"/>
+              <a:cs typeface="Calibri"/>
+              <a:sym typeface="Calibri"/>
+            </a:endParaRPr>
+          </a:p>
+        </p:txBody>
+      </p:sp>
+      <p:sp>
+        <p:nvSpPr>
+          <p:cNvPr id="596" name="Google Shape;596;p29"/>
+          <p:cNvSpPr txBox="1"/>
+          <p:nvPr/>
+        </p:nvSpPr>
+        <p:spPr>
+          <a:xfrm>
+            <a:off x="4857766" y="1328742"/>
+            <a:ext cx="1714505" cy="500064"/>
+          </a:xfrm>
+          <a:prstGeom prst="rect">
+            <a:avLst/>
+          </a:prstGeom>
+          <a:noFill/>
+          <a:ln>
+            <a:noFill/>
+          </a:ln>
+        </p:spPr>
+        <p:txBody>
+          <a:bodyPr anchorCtr="0" anchor="t" bIns="0" lIns="0" spcFirstLastPara="1" rIns="0" wrap="square" tIns="0">
+            <a:noAutofit/>
+          </a:bodyPr>
+          <a:lstStyle/>
+          <a:p>
+            <a:pPr indent="0" lvl="0" marL="0" marR="0" rtl="0" algn="l">
+              <a:lnSpc>
+                <a:spcPct val="130000"/>
+              </a:lnSpc>
+              <a:spcBef>
+                <a:spcPts val="0"/>
+              </a:spcBef>
+              <a:spcAft>
+                <a:spcPts val="0"/>
+              </a:spcAft>
+              <a:buClr>
+                <a:srgbClr val="4A4A5E"/>
+              </a:buClr>
+              <a:buSzPts val="900"/>
+              <a:buFont typeface="Source Sans 3"/>
+              <a:buNone/>
+            </a:pPr>
+            <a:r>
+              <a:rPr b="1" i="0" lang="en" sz="900" u="none" cap="none" strike="noStrike">
+                <a:solidFill>
+                  <a:srgbClr val="4A4A5E"/>
+                </a:solidFill>
+                <a:latin typeface="Source Sans 3"/>
+                <a:ea typeface="Source Sans 3"/>
+                <a:cs typeface="Source Sans 3"/>
+                <a:sym typeface="Source Sans 3"/>
+              </a:rPr>
+              <a:t>Decide what to attack next — using the dependency graph.</a:t>
+            </a:r>
+            <a:endParaRPr b="0" i="0" sz="900" u="none" cap="none" strike="noStrike">
+              <a:solidFill>
+                <a:schemeClr val="dk1"/>
+              </a:solidFill>
+              <a:latin typeface="Calibri"/>
+              <a:ea typeface="Calibri"/>
+              <a:cs typeface="Calibri"/>
+              <a:sym typeface="Calibri"/>
+            </a:endParaRPr>
+          </a:p>
+        </p:txBody>
+      </p:sp>
+      <p:sp>
+        <p:nvSpPr>
+          <p:cNvPr id="597" name="Google Shape;597;p29"/>
+          <p:cNvSpPr/>
+          <p:nvPr/>
+        </p:nvSpPr>
+        <p:spPr>
+          <a:xfrm>
+            <a:off x="4714890" y="2643196"/>
+            <a:ext cx="2000257" cy="1000128"/>
+          </a:xfrm>
+          <a:prstGeom prst="roundRect">
+            <a:avLst>
+              <a:gd fmla="val 5486" name="adj"/>
+            </a:avLst>
+          </a:prstGeom>
+          <a:solidFill>
+            <a:srgbClr val="EDE3D5"/>
+          </a:solidFill>
+          <a:ln cap="flat" cmpd="sng" w="19050">
+            <a:solidFill>
+              <a:srgbClr val="A0631A"/>
+            </a:solidFill>
+            <a:prstDash val="solid"/>
+            <a:round/>
+            <a:headEnd len="sm" w="sm" type="none"/>
+            <a:tailEnd len="sm" w="sm" type="none"/>
+          </a:ln>
+          <a:effectLst>
+            <a:outerShdw blurRad="152400" rotWithShape="0" algn="bl" dir="5400000" dist="50800">
+              <a:srgbClr val="000000">
+                <a:alpha val="5098"/>
+              </a:srgbClr>
+            </a:outerShdw>
+          </a:effectLst>
+        </p:spPr>
+        <p:txBody>
+          <a:bodyPr anchorCtr="0" anchor="ctr" bIns="68575" lIns="68575" spcFirstLastPara="1" rIns="68575" wrap="square" tIns="68575">
+            <a:noAutofit/>
+          </a:bodyPr>
+          <a:lstStyle/>
+          <a:p>
+            <a:pPr indent="0" lvl="0" marL="0" rtl="0" algn="l">
+              <a:spcBef>
+                <a:spcPts val="0"/>
+              </a:spcBef>
+              <a:spcAft>
+                <a:spcPts val="0"/>
+              </a:spcAft>
+              <a:buNone/>
+            </a:pPr>
+            <a:r>
+              <a:t/>
+            </a:r>
+            <a:endParaRPr/>
+          </a:p>
+        </p:txBody>
+      </p:sp>
+      <p:sp>
+        <p:nvSpPr>
+          <p:cNvPr id="598" name="Google Shape;598;p29"/>
+          <p:cNvSpPr/>
+          <p:nvPr/>
+        </p:nvSpPr>
+        <p:spPr>
+          <a:xfrm>
+            <a:off x="4829191" y="2757497"/>
+            <a:ext cx="200026" cy="200026"/>
+          </a:xfrm>
+          <a:prstGeom prst="ellipse">
+            <a:avLst/>
+          </a:prstGeom>
+          <a:solidFill>
+            <a:srgbClr val="FFFFFF"/>
+          </a:solidFill>
+          <a:ln cap="flat" cmpd="sng" w="15225">
+            <a:solidFill>
+              <a:srgbClr val="A0631A"/>
+            </a:solidFill>
+            <a:prstDash val="solid"/>
+            <a:round/>
+            <a:headEnd len="sm" w="sm" type="none"/>
+            <a:tailEnd len="sm" w="sm" type="none"/>
+          </a:ln>
+        </p:spPr>
+        <p:txBody>
+          <a:bodyPr anchorCtr="0" anchor="ctr" bIns="68575" lIns="68575" spcFirstLastPara="1" rIns="68575" wrap="square" tIns="68575">
+            <a:noAutofit/>
+          </a:bodyPr>
+          <a:lstStyle/>
+          <a:p>
+            <a:pPr indent="0" lvl="0" marL="0" rtl="0" algn="l">
+              <a:spcBef>
+                <a:spcPts val="0"/>
+              </a:spcBef>
+              <a:spcAft>
+                <a:spcPts val="0"/>
+              </a:spcAft>
+              <a:buNone/>
+            </a:pPr>
+            <a:r>
+              <a:t/>
+            </a:r>
+            <a:endParaRPr/>
+          </a:p>
+        </p:txBody>
+      </p:sp>
+      <p:sp>
+        <p:nvSpPr>
+          <p:cNvPr id="599" name="Google Shape;599;p29"/>
+          <p:cNvSpPr txBox="1"/>
+          <p:nvPr/>
+        </p:nvSpPr>
+        <p:spPr>
+          <a:xfrm>
+            <a:off x="4829191" y="2757497"/>
+            <a:ext cx="200026" cy="200026"/>
+          </a:xfrm>
+          <a:prstGeom prst="rect">
+            <a:avLst/>
+          </a:prstGeom>
+          <a:noFill/>
+          <a:ln>
+            <a:noFill/>
+          </a:ln>
+        </p:spPr>
+        <p:txBody>
+          <a:bodyPr anchorCtr="0" anchor="ctr" bIns="0" lIns="0" spcFirstLastPara="1" rIns="0" wrap="square" tIns="0">
+            <a:noAutofit/>
+          </a:bodyPr>
+          <a:lstStyle/>
+          <a:p>
+            <a:pPr indent="0" lvl="0" marL="0" marR="0" rtl="0" algn="ctr">
+              <a:spcBef>
+                <a:spcPts val="0"/>
+              </a:spcBef>
+              <a:spcAft>
+                <a:spcPts val="0"/>
+              </a:spcAft>
+              <a:buClr>
+                <a:srgbClr val="A0631A"/>
+              </a:buClr>
+              <a:buSzPts val="900"/>
+              <a:buFont typeface="IBM Plex Mono"/>
+              <a:buNone/>
+            </a:pPr>
+            <a:r>
+              <a:rPr b="1" i="0" lang="en" sz="900" u="none" cap="none" strike="noStrike">
+                <a:solidFill>
+                  <a:srgbClr val="A0631A"/>
+                </a:solidFill>
+                <a:latin typeface="IBM Plex Mono"/>
+                <a:ea typeface="IBM Plex Mono"/>
+                <a:cs typeface="IBM Plex Mono"/>
+                <a:sym typeface="IBM Plex Mono"/>
+              </a:rPr>
+              <a:t>3</a:t>
+            </a:r>
+            <a:endParaRPr b="0" i="0" sz="900" u="none" cap="none" strike="noStrike">
+              <a:solidFill>
+                <a:schemeClr val="dk1"/>
+              </a:solidFill>
+              <a:latin typeface="Calibri"/>
+              <a:ea typeface="Calibri"/>
+              <a:cs typeface="Calibri"/>
+              <a:sym typeface="Calibri"/>
+            </a:endParaRPr>
+          </a:p>
+        </p:txBody>
+      </p:sp>
+      <p:sp>
+        <p:nvSpPr>
+          <p:cNvPr id="600" name="Google Shape;600;p29"/>
+          <p:cNvSpPr txBox="1"/>
+          <p:nvPr/>
+        </p:nvSpPr>
+        <p:spPr>
+          <a:xfrm>
+            <a:off x="5100654" y="2757497"/>
+            <a:ext cx="1428755" cy="200026"/>
+          </a:xfrm>
+          <a:prstGeom prst="rect">
+            <a:avLst/>
+          </a:prstGeom>
+          <a:noFill/>
+          <a:ln>
+            <a:noFill/>
+          </a:ln>
+        </p:spPr>
+        <p:txBody>
+          <a:bodyPr anchorCtr="0" anchor="ctr" bIns="0" lIns="0" spcFirstLastPara="1" rIns="0" wrap="square" tIns="0">
+            <a:noAutofit/>
+          </a:bodyPr>
+          <a:lstStyle/>
+          <a:p>
+            <a:pPr indent="0" lvl="0" marL="0" marR="0" rtl="0" algn="l">
+              <a:spcBef>
+                <a:spcPts val="0"/>
+              </a:spcBef>
+              <a:spcAft>
+                <a:spcPts val="0"/>
+              </a:spcAft>
+              <a:buClr>
+                <a:srgbClr val="1A1A2E"/>
+              </a:buClr>
+              <a:buSzPts val="1400"/>
+              <a:buFont typeface="Source Sans 3"/>
+              <a:buNone/>
+            </a:pPr>
+            <a:r>
+              <a:rPr b="1" i="0" lang="en" sz="1400" u="none" cap="none" strike="noStrike">
+                <a:solidFill>
+                  <a:srgbClr val="1A1A2E"/>
+                </a:solidFill>
+                <a:latin typeface="Source Sans 3"/>
+                <a:ea typeface="Source Sans 3"/>
+                <a:cs typeface="Source Sans 3"/>
+                <a:sym typeface="Source Sans 3"/>
+              </a:rPr>
+              <a:t>Attack</a:t>
+            </a:r>
+            <a:endParaRPr b="0" i="0" sz="1400" u="none" cap="none" strike="noStrike">
+              <a:solidFill>
+                <a:schemeClr val="dk1"/>
+              </a:solidFill>
+              <a:latin typeface="Calibri"/>
+              <a:ea typeface="Calibri"/>
+              <a:cs typeface="Calibri"/>
+              <a:sym typeface="Calibri"/>
+            </a:endParaRPr>
+          </a:p>
+        </p:txBody>
+      </p:sp>
+      <p:sp>
+        <p:nvSpPr>
+          <p:cNvPr id="601" name="Google Shape;601;p29"/>
+          <p:cNvSpPr txBox="1"/>
+          <p:nvPr/>
+        </p:nvSpPr>
+        <p:spPr>
+          <a:xfrm>
+            <a:off x="4857766" y="3043247"/>
+            <a:ext cx="1714505" cy="500064"/>
+          </a:xfrm>
+          <a:prstGeom prst="rect">
+            <a:avLst/>
+          </a:prstGeom>
+          <a:noFill/>
+          <a:ln>
+            <a:noFill/>
+          </a:ln>
+        </p:spPr>
+        <p:txBody>
+          <a:bodyPr anchorCtr="0" anchor="t" bIns="0" lIns="0" spcFirstLastPara="1" rIns="0" wrap="square" tIns="0">
+            <a:noAutofit/>
+          </a:bodyPr>
+          <a:lstStyle/>
+          <a:p>
+            <a:pPr indent="0" lvl="0" marL="0" marR="0" rtl="0" algn="l">
+              <a:lnSpc>
+                <a:spcPct val="130000"/>
+              </a:lnSpc>
+              <a:spcBef>
+                <a:spcPts val="0"/>
+              </a:spcBef>
+              <a:spcAft>
+                <a:spcPts val="0"/>
+              </a:spcAft>
+              <a:buClr>
+                <a:srgbClr val="4A4A5E"/>
+              </a:buClr>
+              <a:buSzPts val="900"/>
+              <a:buFont typeface="Source Sans 3"/>
+              <a:buNone/>
+            </a:pPr>
+            <a:r>
+              <a:rPr b="1" i="0" lang="en" sz="900" u="none" cap="none" strike="noStrike">
+                <a:solidFill>
+                  <a:srgbClr val="4A4A5E"/>
+                </a:solidFill>
+                <a:latin typeface="Source Sans 3"/>
+                <a:ea typeface="Source Sans 3"/>
+                <a:cs typeface="Source Sans 3"/>
+                <a:sym typeface="Source Sans 3"/>
+              </a:rPr>
+              <a:t>Send in a specialist agent. Run the attempt.</a:t>
+            </a:r>
+            <a:endParaRPr b="0" i="0" sz="900" u="none" cap="none" strike="noStrike">
+              <a:solidFill>
+                <a:schemeClr val="dk1"/>
+              </a:solidFill>
+              <a:latin typeface="Calibri"/>
+              <a:ea typeface="Calibri"/>
+              <a:cs typeface="Calibri"/>
+              <a:sym typeface="Calibri"/>
+            </a:endParaRPr>
+          </a:p>
+        </p:txBody>
+      </p:sp>
+      <p:sp>
+        <p:nvSpPr>
+          <p:cNvPr id="602" name="Google Shape;602;p29"/>
+          <p:cNvSpPr/>
+          <p:nvPr/>
+        </p:nvSpPr>
+        <p:spPr>
+          <a:xfrm>
+            <a:off x="2428882" y="2643196"/>
+            <a:ext cx="2000257" cy="1000128"/>
+          </a:xfrm>
+          <a:prstGeom prst="roundRect">
+            <a:avLst>
+              <a:gd fmla="val 5486" name="adj"/>
+            </a:avLst>
+          </a:prstGeom>
+          <a:solidFill>
+            <a:srgbClr val="DEE4DA"/>
+          </a:solidFill>
+          <a:ln cap="flat" cmpd="sng" w="19050">
+            <a:solidFill>
+              <a:srgbClr val="2A6B3C"/>
+            </a:solidFill>
+            <a:prstDash val="solid"/>
+            <a:round/>
+            <a:headEnd len="sm" w="sm" type="none"/>
+            <a:tailEnd len="sm" w="sm" type="none"/>
+          </a:ln>
+          <a:effectLst>
+            <a:outerShdw blurRad="152400" rotWithShape="0" algn="bl" dir="5400000" dist="50800">
+              <a:srgbClr val="000000">
+                <a:alpha val="5098"/>
+              </a:srgbClr>
+            </a:outerShdw>
+          </a:effectLst>
+        </p:spPr>
+        <p:txBody>
+          <a:bodyPr anchorCtr="0" anchor="ctr" bIns="68575" lIns="68575" spcFirstLastPara="1" rIns="68575" wrap="square" tIns="68575">
+            <a:noAutofit/>
+          </a:bodyPr>
+          <a:lstStyle/>
+          <a:p>
+            <a:pPr indent="0" lvl="0" marL="0" rtl="0" algn="l">
+              <a:spcBef>
+                <a:spcPts val="0"/>
+              </a:spcBef>
+              <a:spcAft>
+                <a:spcPts val="0"/>
+              </a:spcAft>
+              <a:buNone/>
+            </a:pPr>
+            <a:r>
+              <a:t/>
+            </a:r>
+            <a:endParaRPr/>
+          </a:p>
+        </p:txBody>
+      </p:sp>
+      <p:sp>
+        <p:nvSpPr>
+          <p:cNvPr id="603" name="Google Shape;603;p29"/>
+          <p:cNvSpPr/>
+          <p:nvPr/>
+        </p:nvSpPr>
+        <p:spPr>
+          <a:xfrm>
+            <a:off x="2543183" y="2757497"/>
+            <a:ext cx="200026" cy="200026"/>
+          </a:xfrm>
+          <a:prstGeom prst="ellipse">
+            <a:avLst/>
+          </a:prstGeom>
+          <a:solidFill>
+            <a:srgbClr val="FFFFFF"/>
+          </a:solidFill>
+          <a:ln cap="flat" cmpd="sng" w="15225">
+            <a:solidFill>
+              <a:srgbClr val="2A6B3C"/>
+            </a:solidFill>
+            <a:prstDash val="solid"/>
+            <a:round/>
+            <a:headEnd len="sm" w="sm" type="none"/>
+            <a:tailEnd len="sm" w="sm" type="none"/>
+          </a:ln>
+        </p:spPr>
+        <p:txBody>
+          <a:bodyPr anchorCtr="0" anchor="ctr" bIns="68575" lIns="68575" spcFirstLastPara="1" rIns="68575" wrap="square" tIns="68575">
+            <a:noAutofit/>
+          </a:bodyPr>
+          <a:lstStyle/>
+          <a:p>
+            <a:pPr indent="0" lvl="0" marL="0" rtl="0" algn="l">
+              <a:spcBef>
+                <a:spcPts val="0"/>
+              </a:spcBef>
+              <a:spcAft>
+                <a:spcPts val="0"/>
+              </a:spcAft>
+              <a:buNone/>
+            </a:pPr>
+            <a:r>
+              <a:t/>
+            </a:r>
+            <a:endParaRPr/>
+          </a:p>
+        </p:txBody>
+      </p:sp>
+      <p:sp>
+        <p:nvSpPr>
+          <p:cNvPr id="604" name="Google Shape;604;p29"/>
+          <p:cNvSpPr txBox="1"/>
+          <p:nvPr/>
+        </p:nvSpPr>
+        <p:spPr>
+          <a:xfrm>
+            <a:off x="2543183" y="2757497"/>
+            <a:ext cx="200026" cy="200026"/>
+          </a:xfrm>
+          <a:prstGeom prst="rect">
+            <a:avLst/>
+          </a:prstGeom>
+          <a:noFill/>
+          <a:ln>
+            <a:noFill/>
+          </a:ln>
+        </p:spPr>
+        <p:txBody>
+          <a:bodyPr anchorCtr="0" anchor="ctr" bIns="0" lIns="0" spcFirstLastPara="1" rIns="0" wrap="square" tIns="0">
+            <a:noAutofit/>
+          </a:bodyPr>
+          <a:lstStyle/>
+          <a:p>
+            <a:pPr indent="0" lvl="0" marL="0" marR="0" rtl="0" algn="ctr">
+              <a:spcBef>
+                <a:spcPts val="0"/>
+              </a:spcBef>
+              <a:spcAft>
+                <a:spcPts val="0"/>
+              </a:spcAft>
+              <a:buClr>
+                <a:srgbClr val="2A6B3C"/>
+              </a:buClr>
+              <a:buSzPts val="900"/>
+              <a:buFont typeface="IBM Plex Mono"/>
+              <a:buNone/>
+            </a:pPr>
+            <a:r>
+              <a:rPr b="1" i="0" lang="en" sz="900" u="none" cap="none" strike="noStrike">
+                <a:solidFill>
+                  <a:srgbClr val="2A6B3C"/>
+                </a:solidFill>
+                <a:latin typeface="IBM Plex Mono"/>
+                <a:ea typeface="IBM Plex Mono"/>
+                <a:cs typeface="IBM Plex Mono"/>
+                <a:sym typeface="IBM Plex Mono"/>
+              </a:rPr>
+              <a:t>4</a:t>
+            </a:r>
+            <a:endParaRPr b="0" i="0" sz="900" u="none" cap="none" strike="noStrike">
+              <a:solidFill>
+                <a:schemeClr val="dk1"/>
+              </a:solidFill>
+              <a:latin typeface="Calibri"/>
+              <a:ea typeface="Calibri"/>
+              <a:cs typeface="Calibri"/>
+              <a:sym typeface="Calibri"/>
+            </a:endParaRPr>
+          </a:p>
+        </p:txBody>
+      </p:sp>
+      <p:sp>
+        <p:nvSpPr>
+          <p:cNvPr id="605" name="Google Shape;605;p29"/>
+          <p:cNvSpPr txBox="1"/>
+          <p:nvPr/>
+        </p:nvSpPr>
+        <p:spPr>
+          <a:xfrm>
+            <a:off x="2814647" y="2757497"/>
+            <a:ext cx="1428755" cy="200026"/>
+          </a:xfrm>
+          <a:prstGeom prst="rect">
+            <a:avLst/>
+          </a:prstGeom>
+          <a:noFill/>
+          <a:ln>
+            <a:noFill/>
+          </a:ln>
+        </p:spPr>
+        <p:txBody>
+          <a:bodyPr anchorCtr="0" anchor="ctr" bIns="0" lIns="0" spcFirstLastPara="1" rIns="0" wrap="square" tIns="0">
+            <a:noAutofit/>
+          </a:bodyPr>
+          <a:lstStyle/>
+          <a:p>
+            <a:pPr indent="0" lvl="0" marL="0" marR="0" rtl="0" algn="l">
+              <a:spcBef>
+                <a:spcPts val="0"/>
+              </a:spcBef>
+              <a:spcAft>
+                <a:spcPts val="0"/>
+              </a:spcAft>
+              <a:buClr>
+                <a:srgbClr val="1A1A2E"/>
+              </a:buClr>
+              <a:buSzPts val="1400"/>
+              <a:buFont typeface="Source Sans 3"/>
+              <a:buNone/>
+            </a:pPr>
+            <a:r>
+              <a:rPr b="1" i="0" lang="en" sz="1400" u="none" cap="none" strike="noStrike">
+                <a:solidFill>
+                  <a:srgbClr val="1A1A2E"/>
+                </a:solidFill>
+                <a:latin typeface="Source Sans 3"/>
+                <a:ea typeface="Source Sans 3"/>
+                <a:cs typeface="Source Sans 3"/>
+                <a:sym typeface="Source Sans 3"/>
+              </a:rPr>
+              <a:t>Learn</a:t>
+            </a:r>
+            <a:endParaRPr b="0" i="0" sz="1400" u="none" cap="none" strike="noStrike">
+              <a:solidFill>
+                <a:schemeClr val="dk1"/>
+              </a:solidFill>
+              <a:latin typeface="Calibri"/>
+              <a:ea typeface="Calibri"/>
+              <a:cs typeface="Calibri"/>
+              <a:sym typeface="Calibri"/>
+            </a:endParaRPr>
+          </a:p>
+        </p:txBody>
+      </p:sp>
+      <p:sp>
+        <p:nvSpPr>
+          <p:cNvPr id="606" name="Google Shape;606;p29"/>
+          <p:cNvSpPr txBox="1"/>
+          <p:nvPr/>
+        </p:nvSpPr>
+        <p:spPr>
+          <a:xfrm>
+            <a:off x="2571758" y="3043247"/>
+            <a:ext cx="1714505" cy="500064"/>
+          </a:xfrm>
+          <a:prstGeom prst="rect">
+            <a:avLst/>
+          </a:prstGeom>
+          <a:noFill/>
+          <a:ln>
+            <a:noFill/>
+          </a:ln>
+        </p:spPr>
+        <p:txBody>
+          <a:bodyPr anchorCtr="0" anchor="t" bIns="0" lIns="0" spcFirstLastPara="1" rIns="0" wrap="square" tIns="0">
+            <a:noAutofit/>
+          </a:bodyPr>
+          <a:lstStyle/>
+          <a:p>
+            <a:pPr indent="0" lvl="0" marL="0" marR="0" rtl="0" algn="l">
+              <a:lnSpc>
+                <a:spcPct val="130000"/>
+              </a:lnSpc>
+              <a:spcBef>
+                <a:spcPts val="0"/>
+              </a:spcBef>
+              <a:spcAft>
+                <a:spcPts val="0"/>
+              </a:spcAft>
+              <a:buClr>
+                <a:srgbClr val="4A4A5E"/>
+              </a:buClr>
+              <a:buSzPts val="900"/>
+              <a:buFont typeface="Source Sans 3"/>
+              <a:buNone/>
+            </a:pPr>
+            <a:r>
+              <a:rPr b="1" i="0" lang="en" sz="900" u="none" cap="none" strike="noStrike">
+                <a:solidFill>
+                  <a:srgbClr val="4A4A5E"/>
+                </a:solidFill>
+                <a:latin typeface="Source Sans 3"/>
+                <a:ea typeface="Source Sans 3"/>
+                <a:cs typeface="Source Sans 3"/>
+                <a:sym typeface="Source Sans 3"/>
+              </a:rPr>
+              <a:t>Did it work? Update the graph. Store the lesson. Repeat.</a:t>
+            </a:r>
+            <a:endParaRPr b="0" i="0" sz="900" u="none" cap="none" strike="noStrike">
+              <a:solidFill>
+                <a:schemeClr val="dk1"/>
+              </a:solidFill>
+              <a:latin typeface="Calibri"/>
+              <a:ea typeface="Calibri"/>
+              <a:cs typeface="Calibri"/>
+              <a:sym typeface="Calibri"/>
+            </a:endParaRPr>
+          </a:p>
+        </p:txBody>
+      </p:sp>
+      <p:sp>
+        <p:nvSpPr>
+          <p:cNvPr id="607" name="Google Shape;607;p29"/>
+          <p:cNvSpPr txBox="1"/>
+          <p:nvPr/>
+        </p:nvSpPr>
+        <p:spPr>
+          <a:xfrm>
+            <a:off x="3571886" y="2071694"/>
+            <a:ext cx="2000257" cy="428626"/>
+          </a:xfrm>
+          <a:prstGeom prst="rect">
+            <a:avLst/>
+          </a:prstGeom>
+          <a:noFill/>
+          <a:ln>
+            <a:noFill/>
+          </a:ln>
+        </p:spPr>
+        <p:txBody>
+          <a:bodyPr anchorCtr="0" anchor="ctr" bIns="0" lIns="0" spcFirstLastPara="1" rIns="0" wrap="square" tIns="0">
+            <a:noAutofit/>
+          </a:bodyPr>
+          <a:lstStyle/>
+          <a:p>
+            <a:pPr indent="0" lvl="0" marL="0" marR="0" rtl="0" algn="ctr">
+              <a:spcBef>
+                <a:spcPts val="0"/>
+              </a:spcBef>
+              <a:spcAft>
+                <a:spcPts val="0"/>
+              </a:spcAft>
+              <a:buClr>
+                <a:srgbClr val="1A1A2E"/>
+              </a:buClr>
+              <a:buSzPts val="1300"/>
+              <a:buFont typeface="Playfair Display"/>
+              <a:buNone/>
+            </a:pPr>
+            <a:r>
+              <a:rPr b="1" i="1" lang="en" sz="1300" u="none" cap="none" strike="noStrike">
+                <a:solidFill>
+                  <a:srgbClr val="1A1A2E"/>
+                </a:solidFill>
+                <a:latin typeface="Playfair Display"/>
+                <a:ea typeface="Playfair Display"/>
+                <a:cs typeface="Playfair Display"/>
+                <a:sym typeface="Playfair Display"/>
+              </a:rPr>
+              <a:t>VDG drives the loop</a:t>
+            </a:r>
+            <a:endParaRPr b="0" i="0" sz="1300" u="none" cap="none" strike="noStrike">
+              <a:solidFill>
+                <a:schemeClr val="dk1"/>
+              </a:solidFill>
+              <a:latin typeface="Calibri"/>
+              <a:ea typeface="Calibri"/>
+              <a:cs typeface="Calibri"/>
+              <a:sym typeface="Calibri"/>
+            </a:endParaRPr>
+          </a:p>
+        </p:txBody>
+      </p:sp>
+      <p:sp>
+        <p:nvSpPr>
+          <p:cNvPr id="608" name="Google Shape;608;p29"/>
+          <p:cNvSpPr/>
+          <p:nvPr/>
+        </p:nvSpPr>
+        <p:spPr>
+          <a:xfrm rot="5400000">
+            <a:off x="4500577" y="1357317"/>
+            <a:ext cx="142876" cy="142876"/>
+          </a:xfrm>
+          <a:prstGeom prst="triangle">
+            <a:avLst>
+              <a:gd fmla="val 50000" name="adj"/>
+            </a:avLst>
+          </a:prstGeom>
+          <a:solidFill>
+            <a:srgbClr val="1A1A2E"/>
+          </a:solidFill>
+          <a:ln>
+            <a:noFill/>
+          </a:ln>
+        </p:spPr>
+        <p:txBody>
+          <a:bodyPr anchorCtr="0" anchor="ctr" bIns="68575" lIns="68575" spcFirstLastPara="1" rIns="68575" wrap="square" tIns="68575">
+            <a:noAutofit/>
+          </a:bodyPr>
+          <a:lstStyle/>
+          <a:p>
+            <a:pPr indent="0" lvl="0" marL="0" rtl="0" algn="l">
+              <a:spcBef>
+                <a:spcPts val="0"/>
+              </a:spcBef>
+              <a:spcAft>
+                <a:spcPts val="0"/>
+              </a:spcAft>
+              <a:buNone/>
+            </a:pPr>
+            <a:r>
+              <a:t/>
+            </a:r>
+            <a:endParaRPr/>
+          </a:p>
+        </p:txBody>
+      </p:sp>
+      <p:sp>
+        <p:nvSpPr>
+          <p:cNvPr id="609" name="Google Shape;609;p29"/>
+          <p:cNvSpPr/>
+          <p:nvPr/>
+        </p:nvSpPr>
+        <p:spPr>
+          <a:xfrm rot="10800000">
+            <a:off x="5643580" y="2214569"/>
+            <a:ext cx="142876" cy="142876"/>
+          </a:xfrm>
+          <a:prstGeom prst="triangle">
+            <a:avLst>
+              <a:gd fmla="val 50000" name="adj"/>
+            </a:avLst>
+          </a:prstGeom>
+          <a:solidFill>
+            <a:srgbClr val="1A1A2E"/>
+          </a:solidFill>
+          <a:ln>
+            <a:noFill/>
+          </a:ln>
+        </p:spPr>
+        <p:txBody>
+          <a:bodyPr anchorCtr="0" anchor="ctr" bIns="68575" lIns="68575" spcFirstLastPara="1" rIns="68575" wrap="square" tIns="68575">
+            <a:noAutofit/>
+          </a:bodyPr>
+          <a:lstStyle/>
+          <a:p>
+            <a:pPr indent="0" lvl="0" marL="0" rtl="0" algn="l">
+              <a:spcBef>
+                <a:spcPts val="0"/>
+              </a:spcBef>
+              <a:spcAft>
+                <a:spcPts val="0"/>
+              </a:spcAft>
+              <a:buNone/>
+            </a:pPr>
+            <a:r>
+              <a:t/>
+            </a:r>
+            <a:endParaRPr/>
+          </a:p>
+        </p:txBody>
+      </p:sp>
+      <p:sp>
+        <p:nvSpPr>
+          <p:cNvPr id="610" name="Google Shape;610;p29"/>
+          <p:cNvSpPr/>
+          <p:nvPr/>
+        </p:nvSpPr>
+        <p:spPr>
+          <a:xfrm rot="-5400000">
+            <a:off x="4500577" y="3071822"/>
+            <a:ext cx="142876" cy="142876"/>
+          </a:xfrm>
+          <a:prstGeom prst="triangle">
+            <a:avLst>
+              <a:gd fmla="val 50000" name="adj"/>
+            </a:avLst>
+          </a:prstGeom>
+          <a:solidFill>
+            <a:srgbClr val="1A1A2E"/>
+          </a:solidFill>
+          <a:ln>
+            <a:noFill/>
+          </a:ln>
+        </p:spPr>
+        <p:txBody>
+          <a:bodyPr anchorCtr="0" anchor="ctr" bIns="68575" lIns="68575" spcFirstLastPara="1" rIns="68575" wrap="square" tIns="68575">
+            <a:noAutofit/>
+          </a:bodyPr>
+          <a:lstStyle/>
+          <a:p>
+            <a:pPr indent="0" lvl="0" marL="0" rtl="0" algn="l">
+              <a:spcBef>
+                <a:spcPts val="0"/>
+              </a:spcBef>
+              <a:spcAft>
+                <a:spcPts val="0"/>
+              </a:spcAft>
+              <a:buNone/>
+            </a:pPr>
+            <a:r>
+              <a:t/>
+            </a:r>
+            <a:endParaRPr/>
+          </a:p>
+        </p:txBody>
+      </p:sp>
+      <p:sp>
+        <p:nvSpPr>
+          <p:cNvPr id="611" name="Google Shape;611;p29"/>
+          <p:cNvSpPr/>
+          <p:nvPr/>
+        </p:nvSpPr>
+        <p:spPr>
+          <a:xfrm>
+            <a:off x="3357573" y="2214569"/>
+            <a:ext cx="142876" cy="142876"/>
+          </a:xfrm>
+          <a:prstGeom prst="triangle">
+            <a:avLst>
+              <a:gd fmla="val 50000" name="adj"/>
+            </a:avLst>
+          </a:prstGeom>
+          <a:solidFill>
+            <a:srgbClr val="1A1A2E"/>
+          </a:solidFill>
+          <a:ln>
+            <a:noFill/>
+          </a:ln>
+        </p:spPr>
+        <p:txBody>
+          <a:bodyPr anchorCtr="0" anchor="ctr" bIns="68575" lIns="68575" spcFirstLastPara="1" rIns="68575" wrap="square" tIns="68575">
+            <a:noAutofit/>
+          </a:bodyPr>
+          <a:lstStyle/>
+          <a:p>
+            <a:pPr indent="0" lvl="0" marL="0" rtl="0" algn="l">
+              <a:spcBef>
+                <a:spcPts val="0"/>
+              </a:spcBef>
+              <a:spcAft>
+                <a:spcPts val="0"/>
+              </a:spcAft>
+              <a:buNone/>
+            </a:pPr>
+            <a:r>
+              <a:t/>
+            </a:r>
+            <a:endParaRPr/>
+          </a:p>
+        </p:txBody>
+      </p:sp>
+      <p:sp>
+        <p:nvSpPr>
+          <p:cNvPr id="612" name="Google Shape;612;p29"/>
+          <p:cNvSpPr txBox="1"/>
+          <p:nvPr/>
+        </p:nvSpPr>
+        <p:spPr>
+          <a:xfrm>
+            <a:off x="571502" y="3929075"/>
+            <a:ext cx="428627" cy="285751"/>
+          </a:xfrm>
+          <a:prstGeom prst="rect">
+            <a:avLst/>
+          </a:prstGeom>
+          <a:noFill/>
+          <a:ln>
+            <a:noFill/>
+          </a:ln>
+        </p:spPr>
+        <p:txBody>
+          <a:bodyPr anchorCtr="0" anchor="t" bIns="0" lIns="0" spcFirstLastPara="1" rIns="0" wrap="square" tIns="0">
+            <a:noAutofit/>
+          </a:bodyPr>
+          <a:lstStyle/>
+          <a:p>
+            <a:pPr indent="0" lvl="0" marL="0" marR="0" rtl="0" algn="l">
+              <a:spcBef>
+                <a:spcPts val="0"/>
+              </a:spcBef>
+              <a:spcAft>
+                <a:spcPts val="0"/>
+              </a:spcAft>
+              <a:buClr>
+                <a:srgbClr val="E7D3CF"/>
+              </a:buClr>
+              <a:buSzPts val="2000"/>
+              <a:buFont typeface="IBM Plex Mono"/>
+              <a:buNone/>
+            </a:pPr>
+            <a:r>
+              <a:rPr b="1" lang="en" sz="2000">
+                <a:solidFill>
+                  <a:schemeClr val="accent3"/>
+                </a:solidFill>
+                <a:latin typeface="IBM Plex Mono"/>
+                <a:ea typeface="IBM Plex Mono"/>
+                <a:cs typeface="IBM Plex Mono"/>
+                <a:sym typeface="IBM Plex Mono"/>
+              </a:rPr>
+              <a:t>0</a:t>
+            </a:r>
+            <a:r>
+              <a:rPr b="1" i="0" lang="en" sz="2000" u="none" cap="none" strike="noStrike">
+                <a:solidFill>
+                  <a:schemeClr val="accent3"/>
+                </a:solidFill>
+                <a:latin typeface="IBM Plex Mono"/>
+                <a:ea typeface="IBM Plex Mono"/>
+                <a:cs typeface="IBM Plex Mono"/>
+                <a:sym typeface="IBM Plex Mono"/>
+              </a:rPr>
+              <a:t>1</a:t>
+            </a:r>
+            <a:endParaRPr b="1" i="0" sz="2000" u="none" cap="none" strike="noStrike">
+              <a:solidFill>
+                <a:schemeClr val="accent3"/>
+              </a:solidFill>
+              <a:latin typeface="Calibri"/>
+              <a:ea typeface="Calibri"/>
+              <a:cs typeface="Calibri"/>
+              <a:sym typeface="Calibri"/>
+            </a:endParaRPr>
+          </a:p>
+        </p:txBody>
+      </p:sp>
+      <p:sp>
+        <p:nvSpPr>
+          <p:cNvPr id="613" name="Google Shape;613;p29"/>
+          <p:cNvSpPr txBox="1"/>
+          <p:nvPr/>
+        </p:nvSpPr>
+        <p:spPr>
+          <a:xfrm>
+            <a:off x="1143004" y="3929075"/>
+            <a:ext cx="3214698" cy="214313"/>
+          </a:xfrm>
+          <a:prstGeom prst="rect">
+            <a:avLst/>
+          </a:prstGeom>
+          <a:noFill/>
+          <a:ln>
+            <a:noFill/>
+          </a:ln>
+        </p:spPr>
+        <p:txBody>
+          <a:bodyPr anchorCtr="0" anchor="t" bIns="0" lIns="0" spcFirstLastPara="1" rIns="0" wrap="square" tIns="0">
+            <a:noAutofit/>
+          </a:bodyPr>
+          <a:lstStyle/>
+          <a:p>
+            <a:pPr indent="0" lvl="0" marL="0" marR="0" rtl="0" algn="l">
+              <a:spcBef>
+                <a:spcPts val="0"/>
+              </a:spcBef>
+              <a:spcAft>
+                <a:spcPts val="0"/>
+              </a:spcAft>
+              <a:buClr>
+                <a:srgbClr val="1A1A2E"/>
+              </a:buClr>
+              <a:buSzPts val="1100"/>
+              <a:buFont typeface="Playfair Display"/>
+              <a:buNone/>
+            </a:pPr>
+            <a:r>
+              <a:rPr b="1" i="0" lang="en" sz="1100" u="none" cap="none" strike="noStrike">
+                <a:solidFill>
+                  <a:srgbClr val="1A1A2E"/>
+                </a:solidFill>
+                <a:latin typeface="Playfair Display"/>
+                <a:ea typeface="Playfair Display"/>
+                <a:cs typeface="Playfair Display"/>
+                <a:sym typeface="Playfair Display"/>
+              </a:rPr>
+              <a:t>Clean Slate per Attempt</a:t>
+            </a:r>
+            <a:endParaRPr b="0" i="0" sz="1100" u="none" cap="none" strike="noStrike">
+              <a:solidFill>
+                <a:schemeClr val="dk1"/>
+              </a:solidFill>
+              <a:latin typeface="Calibri"/>
+              <a:ea typeface="Calibri"/>
+              <a:cs typeface="Calibri"/>
+              <a:sym typeface="Calibri"/>
+            </a:endParaRPr>
+          </a:p>
+        </p:txBody>
+      </p:sp>
+      <p:sp>
+        <p:nvSpPr>
+          <p:cNvPr id="614" name="Google Shape;614;p29"/>
+          <p:cNvSpPr txBox="1"/>
+          <p:nvPr/>
+        </p:nvSpPr>
+        <p:spPr>
+          <a:xfrm>
+            <a:off x="1143004" y="4157676"/>
+            <a:ext cx="3214698" cy="428626"/>
+          </a:xfrm>
+          <a:prstGeom prst="rect">
+            <a:avLst/>
+          </a:prstGeom>
+          <a:noFill/>
+          <a:ln>
+            <a:noFill/>
+          </a:ln>
+        </p:spPr>
+        <p:txBody>
+          <a:bodyPr anchorCtr="0" anchor="b" bIns="0" lIns="0" spcFirstLastPara="1" rIns="0" wrap="square" tIns="0">
+            <a:noAutofit/>
+          </a:bodyPr>
+          <a:lstStyle/>
+          <a:p>
+            <a:pPr indent="0" lvl="0" marL="0" marR="0" rtl="0" algn="l">
+              <a:lnSpc>
+                <a:spcPct val="140000"/>
+              </a:lnSpc>
+              <a:spcBef>
+                <a:spcPts val="0"/>
+              </a:spcBef>
+              <a:spcAft>
+                <a:spcPts val="0"/>
+              </a:spcAft>
+              <a:buClr>
+                <a:srgbClr val="4A4A5E"/>
+              </a:buClr>
+              <a:buSzPts val="800"/>
+              <a:buFont typeface="Source Sans 3"/>
+              <a:buNone/>
+            </a:pPr>
+            <a:r>
+              <a:rPr b="0" i="0" lang="en" sz="1000" u="none" cap="none" strike="noStrike">
+                <a:solidFill>
+                  <a:schemeClr val="dk1"/>
+                </a:solidFill>
+                <a:latin typeface="Source Sans 3"/>
+                <a:ea typeface="Source Sans 3"/>
+                <a:cs typeface="Source Sans 3"/>
+                <a:sym typeface="Source Sans 3"/>
+              </a:rPr>
+              <a:t>Each attack attempt runs with fresh context — no leftover noise from previous steps.</a:t>
+            </a:r>
+            <a:endParaRPr b="0" i="0" sz="1000" u="none" cap="none" strike="noStrike">
+              <a:solidFill>
+                <a:schemeClr val="dk1"/>
+              </a:solidFill>
+              <a:latin typeface="Calibri"/>
+              <a:ea typeface="Calibri"/>
+              <a:cs typeface="Calibri"/>
+              <a:sym typeface="Calibri"/>
+            </a:endParaRPr>
+          </a:p>
+        </p:txBody>
+      </p:sp>
+      <p:sp>
+        <p:nvSpPr>
+          <p:cNvPr id="615" name="Google Shape;615;p29"/>
+          <p:cNvSpPr txBox="1"/>
+          <p:nvPr/>
+        </p:nvSpPr>
+        <p:spPr>
+          <a:xfrm>
+            <a:off x="4786327" y="3929075"/>
+            <a:ext cx="428626" cy="285751"/>
+          </a:xfrm>
+          <a:prstGeom prst="rect">
+            <a:avLst/>
+          </a:prstGeom>
+          <a:noFill/>
+          <a:ln>
+            <a:noFill/>
+          </a:ln>
+        </p:spPr>
+        <p:txBody>
+          <a:bodyPr anchorCtr="0" anchor="t" bIns="0" lIns="0" spcFirstLastPara="1" rIns="0" wrap="square" tIns="0">
+            <a:noAutofit/>
+          </a:bodyPr>
+          <a:lstStyle/>
+          <a:p>
+            <a:pPr indent="0" lvl="0" marL="0" marR="0" rtl="0" algn="l">
+              <a:spcBef>
+                <a:spcPts val="0"/>
+              </a:spcBef>
+              <a:spcAft>
+                <a:spcPts val="0"/>
+              </a:spcAft>
+              <a:buClr>
+                <a:srgbClr val="E7D3CF"/>
+              </a:buClr>
+              <a:buSzPts val="2000"/>
+              <a:buFont typeface="IBM Plex Mono"/>
+              <a:buNone/>
+            </a:pPr>
+            <a:r>
+              <a:rPr b="1" i="0" lang="en" sz="2000" u="none" cap="none" strike="noStrike">
+                <a:solidFill>
+                  <a:schemeClr val="accent3"/>
+                </a:solidFill>
+                <a:latin typeface="IBM Plex Mono"/>
+                <a:ea typeface="IBM Plex Mono"/>
+                <a:cs typeface="IBM Plex Mono"/>
+                <a:sym typeface="IBM Plex Mono"/>
+              </a:rPr>
+              <a:t>02</a:t>
+            </a:r>
+            <a:endParaRPr b="0" i="0" sz="2000" u="none" cap="none" strike="noStrike">
+              <a:solidFill>
+                <a:schemeClr val="accent3"/>
+              </a:solidFill>
+              <a:latin typeface="Calibri"/>
+              <a:ea typeface="Calibri"/>
+              <a:cs typeface="Calibri"/>
+              <a:sym typeface="Calibri"/>
+            </a:endParaRPr>
+          </a:p>
+        </p:txBody>
+      </p:sp>
+      <p:sp>
+        <p:nvSpPr>
+          <p:cNvPr id="616" name="Google Shape;616;p29"/>
+          <p:cNvSpPr txBox="1"/>
+          <p:nvPr/>
+        </p:nvSpPr>
+        <p:spPr>
+          <a:xfrm>
+            <a:off x="5357830" y="3929075"/>
+            <a:ext cx="3214698" cy="214313"/>
+          </a:xfrm>
+          <a:prstGeom prst="rect">
+            <a:avLst/>
+          </a:prstGeom>
+          <a:noFill/>
+          <a:ln>
+            <a:noFill/>
+          </a:ln>
+        </p:spPr>
+        <p:txBody>
+          <a:bodyPr anchorCtr="0" anchor="t" bIns="0" lIns="0" spcFirstLastPara="1" rIns="0" wrap="square" tIns="0">
+            <a:noAutofit/>
+          </a:bodyPr>
+          <a:lstStyle/>
+          <a:p>
+            <a:pPr indent="0" lvl="0" marL="0" marR="0" rtl="0" algn="l">
+              <a:spcBef>
+                <a:spcPts val="0"/>
+              </a:spcBef>
+              <a:spcAft>
+                <a:spcPts val="0"/>
+              </a:spcAft>
+              <a:buClr>
+                <a:srgbClr val="1A1A2E"/>
+              </a:buClr>
+              <a:buSzPts val="1100"/>
+              <a:buFont typeface="Playfair Display"/>
+              <a:buNone/>
+            </a:pPr>
+            <a:r>
+              <a:rPr b="1" i="0" lang="en" sz="1100" u="none" cap="none" strike="noStrike">
+                <a:solidFill>
+                  <a:srgbClr val="1A1A2E"/>
+                </a:solidFill>
+                <a:latin typeface="Playfair Display"/>
+                <a:ea typeface="Playfair Display"/>
+                <a:cs typeface="Playfair Display"/>
+                <a:sym typeface="Playfair Display"/>
+              </a:rPr>
+              <a:t>Facts vs. Guesses</a:t>
+            </a:r>
+            <a:endParaRPr b="0" i="0" sz="1100" u="none" cap="none" strike="noStrike">
+              <a:solidFill>
+                <a:schemeClr val="dk1"/>
+              </a:solidFill>
+              <a:latin typeface="Calibri"/>
+              <a:ea typeface="Calibri"/>
+              <a:cs typeface="Calibri"/>
+              <a:sym typeface="Calibri"/>
+            </a:endParaRPr>
+          </a:p>
+        </p:txBody>
+      </p:sp>
+      <p:sp>
+        <p:nvSpPr>
+          <p:cNvPr id="617" name="Google Shape;617;p29"/>
+          <p:cNvSpPr txBox="1"/>
+          <p:nvPr/>
+        </p:nvSpPr>
+        <p:spPr>
+          <a:xfrm>
+            <a:off x="5357830" y="4157676"/>
+            <a:ext cx="3214698" cy="428626"/>
+          </a:xfrm>
+          <a:prstGeom prst="rect">
+            <a:avLst/>
+          </a:prstGeom>
+          <a:noFill/>
+          <a:ln>
+            <a:noFill/>
+          </a:ln>
+        </p:spPr>
+        <p:txBody>
+          <a:bodyPr anchorCtr="0" anchor="b" bIns="0" lIns="0" spcFirstLastPara="1" rIns="0" wrap="square" tIns="0">
+            <a:noAutofit/>
+          </a:bodyPr>
+          <a:lstStyle/>
+          <a:p>
+            <a:pPr indent="0" lvl="0" marL="0" marR="0" rtl="0" algn="l">
+              <a:lnSpc>
+                <a:spcPct val="140000"/>
+              </a:lnSpc>
+              <a:spcBef>
+                <a:spcPts val="0"/>
+              </a:spcBef>
+              <a:spcAft>
+                <a:spcPts val="0"/>
+              </a:spcAft>
+              <a:buClr>
+                <a:srgbClr val="4A4A5E"/>
+              </a:buClr>
+              <a:buSzPts val="800"/>
+              <a:buFont typeface="Source Sans 3"/>
+              <a:buNone/>
+            </a:pPr>
+            <a:r>
+              <a:rPr b="0" i="0" lang="en" sz="1000" u="none" cap="none" strike="noStrike">
+                <a:solidFill>
+                  <a:schemeClr val="dk1"/>
+                </a:solidFill>
+                <a:latin typeface="Source Sans 3"/>
+                <a:ea typeface="Source Sans 3"/>
+                <a:cs typeface="Source Sans 3"/>
+                <a:sym typeface="Source Sans 3"/>
+              </a:rPr>
+              <a:t>What the agent confirmed is kept strictly separate from what it infers.</a:t>
+            </a:r>
+            <a:endParaRPr b="0" i="0" sz="1000" u="none" cap="none" strike="noStrike">
+              <a:solidFill>
+                <a:schemeClr val="dk1"/>
+              </a:solidFill>
+              <a:latin typeface="Calibri"/>
+              <a:ea typeface="Calibri"/>
+              <a:cs typeface="Calibri"/>
+              <a:sym typeface="Calibri"/>
+            </a:endParaRPr>
+          </a:p>
+        </p:txBody>
+      </p:sp>
+      <p:cxnSp>
+        <p:nvCxnSpPr>
+          <p:cNvPr id="618" name="Google Shape;618;p29"/>
+          <p:cNvCxnSpPr/>
+          <p:nvPr/>
+        </p:nvCxnSpPr>
+        <p:spPr>
+          <a:xfrm>
+            <a:off x="0" y="4886341"/>
+            <a:ext cx="9144029" cy="0"/>
+          </a:xfrm>
+          <a:prstGeom prst="straightConnector1">
+            <a:avLst/>
+          </a:prstGeom>
+          <a:noFill/>
+          <a:ln cap="flat" cmpd="sng" w="9525">
+            <a:solidFill>
+              <a:srgbClr val="D4CFC8"/>
+            </a:solidFill>
+            <a:prstDash val="solid"/>
+            <a:round/>
+            <a:headEnd len="sm" w="sm" type="none"/>
+            <a:tailEnd len="sm" w="sm" type="none"/>
+          </a:ln>
+        </p:spPr>
+      </p:cxnSp>
+      <p:sp>
+        <p:nvSpPr>
+          <p:cNvPr id="619" name="Google Shape;619;p29"/>
+          <p:cNvSpPr txBox="1"/>
+          <p:nvPr/>
+        </p:nvSpPr>
+        <p:spPr>
+          <a:xfrm>
+            <a:off x="7858151" y="5000641"/>
+            <a:ext cx="714377" cy="114300"/>
+          </a:xfrm>
+          <a:prstGeom prst="rect">
+            <a:avLst/>
+          </a:prstGeom>
+          <a:noFill/>
+          <a:ln>
+            <a:noFill/>
+          </a:ln>
+        </p:spPr>
+        <p:txBody>
+          <a:bodyPr anchorCtr="0" anchor="ctr" bIns="0" lIns="0" spcFirstLastPara="1" rIns="0" wrap="square" tIns="0">
+            <a:noAutofit/>
+          </a:bodyPr>
+          <a:lstStyle/>
+          <a:p>
+            <a:pPr indent="0" lvl="0" marL="0" marR="0" rtl="0" algn="r">
+              <a:spcBef>
+                <a:spcPts val="0"/>
+              </a:spcBef>
+              <a:spcAft>
+                <a:spcPts val="0"/>
+              </a:spcAft>
+              <a:buClr>
+                <a:srgbClr val="9A9AAA"/>
+              </a:buClr>
+              <a:buSzPts val="700"/>
+              <a:buFont typeface="IBM Plex Mono"/>
+              <a:buNone/>
+            </a:pPr>
+            <a:r>
+              <a:rPr b="0" i="0" lang="en" sz="700" u="none" cap="none" strike="noStrike">
+                <a:solidFill>
+                  <a:srgbClr val="9A9AAA"/>
+                </a:solidFill>
+                <a:latin typeface="IBM Plex Mono"/>
+                <a:ea typeface="IBM Plex Mono"/>
+                <a:cs typeface="IBM Plex Mono"/>
+                <a:sym typeface="IBM Plex Mono"/>
+              </a:rPr>
+              <a:t>15 / 20</a:t>
+            </a:r>
+            <a:endParaRPr b="0" i="0" sz="700" u="none" cap="none" strike="noStrike">
+              <a:solidFill>
+                <a:schemeClr val="dk1"/>
+              </a:solidFill>
+              <a:latin typeface="Calibri"/>
+              <a:ea typeface="Calibri"/>
+              <a:cs typeface="Calibri"/>
+              <a:sym typeface="Calibri"/>
+            </a:endParaRPr>
+          </a:p>
+        </p:txBody>
+      </p:sp>
+      <p:sp>
+        <p:nvSpPr>
+          <p:cNvPr id="620" name="Google Shape;620;p29"/>
+          <p:cNvSpPr/>
+          <p:nvPr/>
+        </p:nvSpPr>
+        <p:spPr>
+          <a:xfrm>
+            <a:off x="0" y="5122085"/>
+            <a:ext cx="6400820" cy="21431"/>
           </a:xfrm>
           <a:prstGeom prst="rect">
             <a:avLst/>
@@ -26654,7 +28921,7 @@
             <a:tbl>
               <a:tblPr>
                 <a:noFill/>
-                <a:tableStyleId>{A18C39B4-9265-4439-AC4B-7F529FEAC824}</a:tableStyleId>
+                <a:tableStyleId>{25C997F3-B552-403A-BB00-0357DBA40DC2}</a:tableStyleId>
               </a:tblPr>
               <a:tblGrid>
                 <a:gridCol w="4000500"/>
@@ -34244,7 +36511,7 @@
             <a:tbl>
               <a:tblPr>
                 <a:noFill/>
-                <a:tableStyleId>{A18C39B4-9265-4439-AC4B-7F529FEAC824}</a:tableStyleId>
+                <a:tableStyleId>{25C997F3-B552-403A-BB00-0357DBA40DC2}</a:tableStyleId>
               </a:tblPr>
               <a:tblGrid>
                 <a:gridCol w="1200150"/>
@@ -40254,6 +42521,285 @@
 </file>
 
 <file path=ppt/theme/theme2.xml><?xml version="1.0" encoding="utf-8"?>
+<a:theme xmlns:a="http://schemas.openxmlformats.org/drawingml/2006/main" xmlns:r="http://schemas.openxmlformats.org/officeDocument/2006/relationships" name="Simple Light">
+  <a:themeElements>
+    <a:clrScheme name="Simple Light">
+      <a:dk1>
+        <a:srgbClr val="000000"/>
+      </a:dk1>
+      <a:lt1>
+        <a:srgbClr val="FFFFFF"/>
+      </a:lt1>
+      <a:dk2>
+        <a:srgbClr val="595959"/>
+      </a:dk2>
+      <a:lt2>
+        <a:srgbClr val="EEEEEE"/>
+      </a:lt2>
+      <a:accent1>
+        <a:srgbClr val="4285F4"/>
+      </a:accent1>
+      <a:accent2>
+        <a:srgbClr val="212121"/>
+      </a:accent2>
+      <a:accent3>
+        <a:srgbClr val="78909C"/>
+      </a:accent3>
+      <a:accent4>
+        <a:srgbClr val="FFAB40"/>
+      </a:accent4>
+      <a:accent5>
+        <a:srgbClr val="0097A7"/>
+      </a:accent5>
+      <a:accent6>
+        <a:srgbClr val="EEFF41"/>
+      </a:accent6>
+      <a:hlink>
+        <a:srgbClr val="0097A7"/>
+      </a:hlink>
+      <a:folHlink>
+        <a:srgbClr val="0097A7"/>
+      </a:folHlink>
+    </a:clrScheme>
+    <a:fontScheme name="Office">
+      <a:majorFont>
+        <a:latin typeface="Arial"/>
+        <a:ea typeface=""/>
+        <a:cs typeface=""/>
+        <a:font script="Jpan" typeface="ＭＳ Ｐゴシック"/>
+        <a:font script="Hang" typeface="맑은 고딕"/>
+        <a:font script="Hans" typeface="宋体"/>
+        <a:font script="Hant" typeface="新細明體"/>
+        <a:font script="Arab" typeface="Times New Roman"/>
+        <a:font script="Hebr" typeface="Times New Roman"/>
+        <a:font script="Thai" typeface="Angsana New"/>
+        <a:font script="Ethi" typeface="Nyala"/>
+        <a:font script="Beng" typeface="Vrinda"/>
+        <a:font script="Gujr" typeface="Shruti"/>
+        <a:font script="Khmr" typeface="MoolBoran"/>
+        <a:font script="Knda" typeface="Tunga"/>
+        <a:font script="Guru" typeface="Raavi"/>
+        <a:font script="Cans" typeface="Euphemia"/>
+        <a:font script="Cher" typeface="Plantagenet Cherokee"/>
+        <a:font script="Yiii" typeface="Microsoft Yi Baiti"/>
+        <a:font script="Tibt" typeface="Microsoft Himalaya"/>
+        <a:font script="Thaa" typeface="MV Boli"/>
+        <a:font script="Deva" typeface="Mangal"/>
+        <a:font script="Telu" typeface="Gautami"/>
+        <a:font script="Taml" typeface="Latha"/>
+        <a:font script="Syrc" typeface="Estrangelo Edessa"/>
+        <a:font script="Orya" typeface="Kalinga"/>
+        <a:font script="Mlym" typeface="Kartika"/>
+        <a:font script="Laoo" typeface="DokChampa"/>
+        <a:font script="Sinh" typeface="Iskoola Pota"/>
+        <a:font script="Mong" typeface="Mongolian Baiti"/>
+        <a:font script="Viet" typeface="Times New Roman"/>
+        <a:font script="Uigh" typeface="Microsoft Uighur"/>
+        <a:font script="Geor" typeface="Sylfaen"/>
+      </a:majorFont>
+      <a:minorFont>
+        <a:latin typeface="Arial"/>
+        <a:ea typeface=""/>
+        <a:cs typeface=""/>
+        <a:font script="Jpan" typeface="ＭＳ Ｐゴシック"/>
+        <a:font script="Hang" typeface="맑은 고딕"/>
+        <a:font script="Hans" typeface="宋体"/>
+        <a:font script="Hant" typeface="新細明體"/>
+        <a:font script="Arab" typeface="Arial"/>
+        <a:font script="Hebr" typeface="Arial"/>
+        <a:font script="Thai" typeface="Cordia New"/>
+        <a:font script="Ethi" typeface="Nyala"/>
+        <a:font script="Beng" typeface="Vrinda"/>
+        <a:font script="Gujr" typeface="Shruti"/>
+        <a:font script="Khmr" typeface="DaunPenh"/>
+        <a:font script="Knda" typeface="Tunga"/>
+        <a:font script="Guru" typeface="Raavi"/>
+        <a:font script="Cans" typeface="Euphemia"/>
+        <a:font script="Cher" typeface="Plantagenet Cherokee"/>
+        <a:font script="Yiii" typeface="Microsoft Yi Baiti"/>
+        <a:font script="Tibt" typeface="Microsoft Himalaya"/>
+        <a:font script="Thaa" typeface="MV Boli"/>
+        <a:font script="Deva" typeface="Mangal"/>
+        <a:font script="Telu" typeface="Gautami"/>
+        <a:font script="Taml" typeface="Latha"/>
+        <a:font script="Syrc" typeface="Estrangelo Edessa"/>
+        <a:font script="Orya" typeface="Kalinga"/>
+        <a:font script="Mlym" typeface="Kartika"/>
+        <a:font script="Laoo" typeface="DokChampa"/>
+        <a:font script="Sinh" typeface="Iskoola Pota"/>
+        <a:font script="Mong" typeface="Mongolian Baiti"/>
+        <a:font script="Viet" typeface="Arial"/>
+        <a:font script="Uigh" typeface="Microsoft Uighur"/>
+        <a:font script="Geor" typeface="Sylfaen"/>
+      </a:minorFont>
+    </a:fontScheme>
+    <a:fmtScheme name="Office">
+      <a:fillStyleLst>
+        <a:solidFill>
+          <a:schemeClr val="phClr"/>
+        </a:solidFill>
+        <a:gradFill rotWithShape="1">
+          <a:gsLst>
+            <a:gs pos="0">
+              <a:schemeClr val="phClr">
+                <a:tint val="50000"/>
+                <a:satMod val="300000"/>
+              </a:schemeClr>
+            </a:gs>
+            <a:gs pos="35000">
+              <a:schemeClr val="phClr">
+                <a:tint val="37000"/>
+                <a:satMod val="300000"/>
+              </a:schemeClr>
+            </a:gs>
+            <a:gs pos="100000">
+              <a:schemeClr val="phClr">
+                <a:tint val="15000"/>
+                <a:satMod val="350000"/>
+              </a:schemeClr>
+            </a:gs>
+          </a:gsLst>
+          <a:lin ang="16200000" scaled="1"/>
+        </a:gradFill>
+        <a:gradFill rotWithShape="1">
+          <a:gsLst>
+            <a:gs pos="0">
+              <a:schemeClr val="phClr">
+                <a:tint val="100000"/>
+                <a:shade val="100000"/>
+                <a:satMod val="130000"/>
+              </a:schemeClr>
+            </a:gs>
+            <a:gs pos="100000">
+              <a:schemeClr val="phClr">
+                <a:tint val="50000"/>
+                <a:shade val="100000"/>
+                <a:satMod val="350000"/>
+              </a:schemeClr>
+            </a:gs>
+          </a:gsLst>
+          <a:lin ang="16200000" scaled="0"/>
+        </a:gradFill>
+      </a:fillStyleLst>
+      <a:lnStyleLst>
+        <a:ln w="9525" cap="flat" cmpd="sng" algn="ctr">
+          <a:solidFill>
+            <a:schemeClr val="phClr">
+              <a:shade val="95000"/>
+              <a:satMod val="105000"/>
+            </a:schemeClr>
+          </a:solidFill>
+          <a:prstDash val="solid"/>
+        </a:ln>
+        <a:ln w="25400" cap="flat" cmpd="sng" algn="ctr">
+          <a:solidFill>
+            <a:schemeClr val="phClr"/>
+          </a:solidFill>
+          <a:prstDash val="solid"/>
+        </a:ln>
+        <a:ln w="38100" cap="flat" cmpd="sng" algn="ctr">
+          <a:solidFill>
+            <a:schemeClr val="phClr"/>
+          </a:solidFill>
+          <a:prstDash val="solid"/>
+        </a:ln>
+      </a:lnStyleLst>
+      <a:effectStyleLst>
+        <a:effectStyle>
+          <a:effectLst>
+            <a:outerShdw blurRad="40000" dist="20000" dir="5400000" rotWithShape="0">
+              <a:srgbClr val="000000">
+                <a:alpha val="38000"/>
+              </a:srgbClr>
+            </a:outerShdw>
+          </a:effectLst>
+        </a:effectStyle>
+        <a:effectStyle>
+          <a:effectLst>
+            <a:outerShdw blurRad="40000" dist="23000" dir="5400000" rotWithShape="0">
+              <a:srgbClr val="000000">
+                <a:alpha val="35000"/>
+              </a:srgbClr>
+            </a:outerShdw>
+          </a:effectLst>
+        </a:effectStyle>
+        <a:effectStyle>
+          <a:effectLst>
+            <a:outerShdw blurRad="40000" dist="23000" dir="5400000" rotWithShape="0">
+              <a:srgbClr val="000000">
+                <a:alpha val="35000"/>
+              </a:srgbClr>
+            </a:outerShdw>
+          </a:effectLst>
+          <a:scene3d>
+            <a:camera prst="orthographicFront">
+              <a:rot lat="0" lon="0" rev="0"/>
+            </a:camera>
+            <a:lightRig rig="threePt" dir="t">
+              <a:rot lat="0" lon="0" rev="1200000"/>
+            </a:lightRig>
+          </a:scene3d>
+          <a:sp3d>
+            <a:bevelT w="63500" h="25400"/>
+          </a:sp3d>
+        </a:effectStyle>
+      </a:effectStyleLst>
+      <a:bgFillStyleLst>
+        <a:solidFill>
+          <a:schemeClr val="phClr"/>
+        </a:solidFill>
+        <a:gradFill rotWithShape="1">
+          <a:gsLst>
+            <a:gs pos="0">
+              <a:schemeClr val="phClr">
+                <a:tint val="40000"/>
+                <a:satMod val="350000"/>
+              </a:schemeClr>
+            </a:gs>
+            <a:gs pos="40000">
+              <a:schemeClr val="phClr">
+                <a:tint val="45000"/>
+                <a:shade val="99000"/>
+                <a:satMod val="350000"/>
+              </a:schemeClr>
+            </a:gs>
+            <a:gs pos="100000">
+              <a:schemeClr val="phClr">
+                <a:shade val="20000"/>
+                <a:satMod val="255000"/>
+              </a:schemeClr>
+            </a:gs>
+          </a:gsLst>
+          <a:path path="circle">
+            <a:fillToRect l="50000" t="-80000" r="50000" b="180000"/>
+          </a:path>
+        </a:gradFill>
+        <a:gradFill rotWithShape="1">
+          <a:gsLst>
+            <a:gs pos="0">
+              <a:schemeClr val="phClr">
+                <a:tint val="80000"/>
+                <a:satMod val="300000"/>
+              </a:schemeClr>
+            </a:gs>
+            <a:gs pos="100000">
+              <a:schemeClr val="phClr">
+                <a:shade val="30000"/>
+                <a:satMod val="200000"/>
+              </a:schemeClr>
+            </a:gs>
+          </a:gsLst>
+          <a:path path="circle">
+            <a:fillToRect l="50000" t="50000" r="50000" b="50000"/>
+          </a:path>
+        </a:gradFill>
+      </a:bgFillStyleLst>
+    </a:fmtScheme>
+  </a:themeElements>
+</a:theme>
+</file>
+
+<file path=ppt/theme/theme3.xml><?xml version="1.0" encoding="utf-8"?>
 <a:theme xmlns:a="http://schemas.openxmlformats.org/drawingml/2006/main" xmlns:r="http://schemas.openxmlformats.org/officeDocument/2006/relationships">
   <a:themeElements>
     <a:clrScheme name="Default">
@@ -40530,283 +43076,4 @@
     </a:fmtScheme>
   </a:themeElements>
 </a:theme>
-</file>
-
-<file path=ppt/theme/theme3.xml><?xml version="1.0" encoding="utf-8"?>
-<a:theme xmlns:a="http://schemas.openxmlformats.org/drawingml/2006/main" xmlns:r="http://schemas.openxmlformats.org/officeDocument/2006/relationships" name="Simple Light">
-  <a:themeElements>
-    <a:clrScheme name="Simple Light">
-      <a:dk1>
-        <a:srgbClr val="000000"/>
-      </a:dk1>
-      <a:lt1>
-        <a:srgbClr val="FFFFFF"/>
-      </a:lt1>
-      <a:dk2>
-        <a:srgbClr val="595959"/>
-      </a:dk2>
-      <a:lt2>
-        <a:srgbClr val="EEEEEE"/>
-      </a:lt2>
-      <a:accent1>
-        <a:srgbClr val="4285F4"/>
-      </a:accent1>
-      <a:accent2>
-        <a:srgbClr val="212121"/>
-      </a:accent2>
-      <a:accent3>
-        <a:srgbClr val="78909C"/>
-      </a:accent3>
-      <a:accent4>
-        <a:srgbClr val="FFAB40"/>
-      </a:accent4>
-      <a:accent5>
-        <a:srgbClr val="0097A7"/>
-      </a:accent5>
-      <a:accent6>
-        <a:srgbClr val="EEFF41"/>
-      </a:accent6>
-      <a:hlink>
-        <a:srgbClr val="0097A7"/>
-      </a:hlink>
-      <a:folHlink>
-        <a:srgbClr val="0097A7"/>
-      </a:folHlink>
-    </a:clrScheme>
-    <a:fontScheme name="Office">
-      <a:majorFont>
-        <a:latin typeface="Arial"/>
-        <a:ea typeface=""/>
-        <a:cs typeface=""/>
-        <a:font script="Jpan" typeface="ＭＳ Ｐゴシック"/>
-        <a:font script="Hang" typeface="맑은 고딕"/>
-        <a:font script="Hans" typeface="宋体"/>
-        <a:font script="Hant" typeface="新細明體"/>
-        <a:font script="Arab" typeface="Times New Roman"/>
-        <a:font script="Hebr" typeface="Times New Roman"/>
-        <a:font script="Thai" typeface="Angsana New"/>
-        <a:font script="Ethi" typeface="Nyala"/>
-        <a:font script="Beng" typeface="Vrinda"/>
-        <a:font script="Gujr" typeface="Shruti"/>
-        <a:font script="Khmr" typeface="MoolBoran"/>
-        <a:font script="Knda" typeface="Tunga"/>
-        <a:font script="Guru" typeface="Raavi"/>
-        <a:font script="Cans" typeface="Euphemia"/>
-        <a:font script="Cher" typeface="Plantagenet Cherokee"/>
-        <a:font script="Yiii" typeface="Microsoft Yi Baiti"/>
-        <a:font script="Tibt" typeface="Microsoft Himalaya"/>
-        <a:font script="Thaa" typeface="MV Boli"/>
-        <a:font script="Deva" typeface="Mangal"/>
-        <a:font script="Telu" typeface="Gautami"/>
-        <a:font script="Taml" typeface="Latha"/>
-        <a:font script="Syrc" typeface="Estrangelo Edessa"/>
-        <a:font script="Orya" typeface="Kalinga"/>
-        <a:font script="Mlym" typeface="Kartika"/>
-        <a:font script="Laoo" typeface="DokChampa"/>
-        <a:font script="Sinh" typeface="Iskoola Pota"/>
-        <a:font script="Mong" typeface="Mongolian Baiti"/>
-        <a:font script="Viet" typeface="Times New Roman"/>
-        <a:font script="Uigh" typeface="Microsoft Uighur"/>
-        <a:font script="Geor" typeface="Sylfaen"/>
-      </a:majorFont>
-      <a:minorFont>
-        <a:latin typeface="Arial"/>
-        <a:ea typeface=""/>
-        <a:cs typeface=""/>
-        <a:font script="Jpan" typeface="ＭＳ Ｐゴシック"/>
-        <a:font script="Hang" typeface="맑은 고딕"/>
-        <a:font script="Hans" typeface="宋体"/>
-        <a:font script="Hant" typeface="新細明體"/>
-        <a:font script="Arab" typeface="Arial"/>
-        <a:font script="Hebr" typeface="Arial"/>
-        <a:font script="Thai" typeface="Cordia New"/>
-        <a:font script="Ethi" typeface="Nyala"/>
-        <a:font script="Beng" typeface="Vrinda"/>
-        <a:font script="Gujr" typeface="Shruti"/>
-        <a:font script="Khmr" typeface="DaunPenh"/>
-        <a:font script="Knda" typeface="Tunga"/>
-        <a:font script="Guru" typeface="Raavi"/>
-        <a:font script="Cans" typeface="Euphemia"/>
-        <a:font script="Cher" typeface="Plantagenet Cherokee"/>
-        <a:font script="Yiii" typeface="Microsoft Yi Baiti"/>
-        <a:font script="Tibt" typeface="Microsoft Himalaya"/>
-        <a:font script="Thaa" typeface="MV Boli"/>
-        <a:font script="Deva" typeface="Mangal"/>
-        <a:font script="Telu" typeface="Gautami"/>
-        <a:font script="Taml" typeface="Latha"/>
-        <a:font script="Syrc" typeface="Estrangelo Edessa"/>
-        <a:font script="Orya" typeface="Kalinga"/>
-        <a:font script="Mlym" typeface="Kartika"/>
-        <a:font script="Laoo" typeface="DokChampa"/>
-        <a:font script="Sinh" typeface="Iskoola Pota"/>
-        <a:font script="Mong" typeface="Mongolian Baiti"/>
-        <a:font script="Viet" typeface="Arial"/>
-        <a:font script="Uigh" typeface="Microsoft Uighur"/>
-        <a:font script="Geor" typeface="Sylfaen"/>
-      </a:minorFont>
-    </a:fontScheme>
-    <a:fmtScheme name="Office">
-      <a:fillStyleLst>
-        <a:solidFill>
-          <a:schemeClr val="phClr"/>
-        </a:solidFill>
-        <a:gradFill rotWithShape="1">
-          <a:gsLst>
-            <a:gs pos="0">
-              <a:schemeClr val="phClr">
-                <a:tint val="50000"/>
-                <a:satMod val="300000"/>
-              </a:schemeClr>
-            </a:gs>
-            <a:gs pos="35000">
-              <a:schemeClr val="phClr">
-                <a:tint val="37000"/>
-                <a:satMod val="300000"/>
-              </a:schemeClr>
-            </a:gs>
-            <a:gs pos="100000">
-              <a:schemeClr val="phClr">
-                <a:tint val="15000"/>
-                <a:satMod val="350000"/>
-              </a:schemeClr>
-            </a:gs>
-          </a:gsLst>
-          <a:lin ang="16200000" scaled="1"/>
-        </a:gradFill>
-        <a:gradFill rotWithShape="1">
-          <a:gsLst>
-            <a:gs pos="0">
-              <a:schemeClr val="phClr">
-                <a:tint val="100000"/>
-                <a:shade val="100000"/>
-                <a:satMod val="130000"/>
-              </a:schemeClr>
-            </a:gs>
-            <a:gs pos="100000">
-              <a:schemeClr val="phClr">
-                <a:tint val="50000"/>
-                <a:shade val="100000"/>
-                <a:satMod val="350000"/>
-              </a:schemeClr>
-            </a:gs>
-          </a:gsLst>
-          <a:lin ang="16200000" scaled="0"/>
-        </a:gradFill>
-      </a:fillStyleLst>
-      <a:lnStyleLst>
-        <a:ln w="9525" cap="flat" cmpd="sng" algn="ctr">
-          <a:solidFill>
-            <a:schemeClr val="phClr">
-              <a:shade val="95000"/>
-              <a:satMod val="105000"/>
-            </a:schemeClr>
-          </a:solidFill>
-          <a:prstDash val="solid"/>
-        </a:ln>
-        <a:ln w="25400" cap="flat" cmpd="sng" algn="ctr">
-          <a:solidFill>
-            <a:schemeClr val="phClr"/>
-          </a:solidFill>
-          <a:prstDash val="solid"/>
-        </a:ln>
-        <a:ln w="38100" cap="flat" cmpd="sng" algn="ctr">
-          <a:solidFill>
-            <a:schemeClr val="phClr"/>
-          </a:solidFill>
-          <a:prstDash val="solid"/>
-        </a:ln>
-      </a:lnStyleLst>
-      <a:effectStyleLst>
-        <a:effectStyle>
-          <a:effectLst>
-            <a:outerShdw blurRad="40000" dist="20000" dir="5400000" rotWithShape="0">
-              <a:srgbClr val="000000">
-                <a:alpha val="38000"/>
-              </a:srgbClr>
-            </a:outerShdw>
-          </a:effectLst>
-        </a:effectStyle>
-        <a:effectStyle>
-          <a:effectLst>
-            <a:outerShdw blurRad="40000" dist="23000" dir="5400000" rotWithShape="0">
-              <a:srgbClr val="000000">
-                <a:alpha val="35000"/>
-              </a:srgbClr>
-            </a:outerShdw>
-          </a:effectLst>
-        </a:effectStyle>
-        <a:effectStyle>
-          <a:effectLst>
-            <a:outerShdw blurRad="40000" dist="23000" dir="5400000" rotWithShape="0">
-              <a:srgbClr val="000000">
-                <a:alpha val="35000"/>
-              </a:srgbClr>
-            </a:outerShdw>
-          </a:effectLst>
-          <a:scene3d>
-            <a:camera prst="orthographicFront">
-              <a:rot lat="0" lon="0" rev="0"/>
-            </a:camera>
-            <a:lightRig rig="threePt" dir="t">
-              <a:rot lat="0" lon="0" rev="1200000"/>
-            </a:lightRig>
-          </a:scene3d>
-          <a:sp3d>
-            <a:bevelT w="63500" h="25400"/>
-          </a:sp3d>
-        </a:effectStyle>
-      </a:effectStyleLst>
-      <a:bgFillStyleLst>
-        <a:solidFill>
-          <a:schemeClr val="phClr"/>
-        </a:solidFill>
-        <a:gradFill rotWithShape="1">
-          <a:gsLst>
-            <a:gs pos="0">
-              <a:schemeClr val="phClr">
-                <a:tint val="40000"/>
-                <a:satMod val="350000"/>
-              </a:schemeClr>
-            </a:gs>
-            <a:gs pos="40000">
-              <a:schemeClr val="phClr">
-                <a:tint val="45000"/>
-                <a:shade val="99000"/>
-                <a:satMod val="350000"/>
-              </a:schemeClr>
-            </a:gs>
-            <a:gs pos="100000">
-              <a:schemeClr val="phClr">
-                <a:shade val="20000"/>
-                <a:satMod val="255000"/>
-              </a:schemeClr>
-            </a:gs>
-          </a:gsLst>
-          <a:path path="circle">
-            <a:fillToRect l="50000" t="-80000" r="50000" b="180000"/>
-          </a:path>
-        </a:gradFill>
-        <a:gradFill rotWithShape="1">
-          <a:gsLst>
-            <a:gs pos="0">
-              <a:schemeClr val="phClr">
-                <a:tint val="80000"/>
-                <a:satMod val="300000"/>
-              </a:schemeClr>
-            </a:gs>
-            <a:gs pos="100000">
-              <a:schemeClr val="phClr">
-                <a:shade val="30000"/>
-                <a:satMod val="200000"/>
-              </a:schemeClr>
-            </a:gs>
-          </a:gsLst>
-          <a:path path="circle">
-            <a:fillToRect l="50000" t="50000" r="50000" b="50000"/>
-          </a:path>
-        </a:gradFill>
-      </a:bgFillStyleLst>
-    </a:fmtScheme>
-  </a:themeElements>
-</a:theme>
 </file>
</xml_diff>